<commit_message>
Alinear presentación con tablas de fases y roles
Co-authored-by: TheXKnight117 <TheXKnight117@users.noreply.github.com>
</commit_message>
<xml_diff>
--- a/Presentacion_Dolce_Vita_Proceso_Unificado.pptx
+++ b/Presentacion_Dolce_Vita_Proceso_Unificado.pptx
@@ -9591,11 +9591,11 @@
           <a:p>
             <a:pPr>
               <a:spcAft>
-                <a:spcPts val="1000"/>
+                <a:spcPts val="700"/>
               </a:spcAft>
             </a:pPr>
             <a:r>
-              <a:rPr sz="1300">
+              <a:rPr sz="1200">
                 <a:solidFill>
                   <a:srgbClr val="2B2A26"/>
                 </a:solidFill>
@@ -9607,11 +9607,11 @@
           <a:p>
             <a:pPr>
               <a:spcAft>
-                <a:spcPts val="1000"/>
+                <a:spcPts val="700"/>
               </a:spcAft>
             </a:pPr>
             <a:r>
-              <a:rPr sz="1300">
+              <a:rPr sz="1200">
                 <a:solidFill>
                   <a:srgbClr val="2B2A26"/>
                 </a:solidFill>
@@ -9623,11 +9623,11 @@
           <a:p>
             <a:pPr>
               <a:spcAft>
-                <a:spcPts val="1000"/>
+                <a:spcPts val="700"/>
               </a:spcAft>
             </a:pPr>
             <a:r>
-              <a:rPr sz="1300">
+              <a:rPr sz="1200">
                 <a:solidFill>
                   <a:srgbClr val="2B2A26"/>
                 </a:solidFill>
@@ -9639,11 +9639,11 @@
           <a:p>
             <a:pPr>
               <a:spcAft>
-                <a:spcPts val="1000"/>
+                <a:spcPts val="700"/>
               </a:spcAft>
             </a:pPr>
             <a:r>
-              <a:rPr sz="1300">
+              <a:rPr sz="1200">
                 <a:solidFill>
                   <a:srgbClr val="2B2A26"/>
                 </a:solidFill>
@@ -9655,11 +9655,11 @@
           <a:p>
             <a:pPr>
               <a:spcAft>
-                <a:spcPts val="1000"/>
+                <a:spcPts val="700"/>
               </a:spcAft>
             </a:pPr>
             <a:r>
-              <a:rPr sz="1300">
+              <a:rPr sz="1200">
                 <a:solidFill>
                   <a:srgbClr val="2B2A26"/>
                 </a:solidFill>
@@ -9671,11 +9671,11 @@
           <a:p>
             <a:pPr>
               <a:spcAft>
-                <a:spcPts val="1000"/>
+                <a:spcPts val="700"/>
               </a:spcAft>
             </a:pPr>
             <a:r>
-              <a:rPr sz="1300">
+              <a:rPr sz="1200">
                 <a:solidFill>
                   <a:srgbClr val="2B2A26"/>
                 </a:solidFill>
@@ -9687,17 +9687,49 @@
           <a:p>
             <a:pPr>
               <a:spcAft>
-                <a:spcPts val="1000"/>
+                <a:spcPts val="700"/>
               </a:spcAft>
             </a:pPr>
             <a:r>
-              <a:rPr sz="1300">
+              <a:rPr sz="1200">
                 <a:solidFill>
                   <a:srgbClr val="2B2A26"/>
                 </a:solidFill>
                 <a:latin typeface="Aptos"/>
               </a:rPr>
               <a:t>Santo Tomás Online. (s. f.). Diseño de software: Apunte semanal, semana 3 [Material de asignatura].</a:t>
+            </a:r>
+          </a:p>
+          <a:p>
+            <a:pPr>
+              <a:spcAft>
+                <a:spcPts val="700"/>
+              </a:spcAft>
+            </a:pPr>
+            <a:r>
+              <a:rPr sz="1200">
+                <a:solidFill>
+                  <a:srgbClr val="2B2A26"/>
+                </a:solidFill>
+                <a:latin typeface="Aptos"/>
+              </a:rPr>
+              <a:t>Santo Tomás Online. (s. f.). Tabla de fases del Proceso Unificado de Desarrollo de Software [Material de asignatura].</a:t>
+            </a:r>
+          </a:p>
+          <a:p>
+            <a:pPr>
+              <a:spcAft>
+                <a:spcPts val="700"/>
+              </a:spcAft>
+            </a:pPr>
+            <a:r>
+              <a:rPr sz="1200">
+                <a:solidFill>
+                  <a:srgbClr val="2B2A26"/>
+                </a:solidFill>
+                <a:latin typeface="Aptos"/>
+              </a:rPr>
+              <a:t>Santo Tomás Online. (s. f.). Tabla de roles y responsabilidades en el Proceso Unificado [Material de asignatura].</a:t>
             </a:r>
           </a:p>
         </p:txBody>
@@ -12858,7 +12890,7 @@
                 </a:solidFill>
                 <a:latin typeface="Aptos"/>
               </a:rPr>
-              <a:t>La responsabilidad es explícita, pero el trabajo se coordina alrededor de los casos de uso.</a:t>
+              <a:t>Responsabilidades alineadas con la Tabla de Roles del material de la asignatura.</a:t>
             </a:r>
           </a:p>
         </p:txBody>
@@ -12985,7 +13017,7 @@
         <p:spPr>
           <a:xfrm>
             <a:off x="640080" y="1874519"/>
-            <a:ext cx="5230368" cy="850392"/>
+            <a:ext cx="5230368" cy="1078992"/>
           </a:xfrm>
           <a:prstGeom prst="roundRect">
             <a:avLst/>
@@ -13030,7 +13062,7 @@
         <p:spPr>
           <a:xfrm>
             <a:off x="640080" y="1874519"/>
-            <a:ext cx="73152" cy="850392"/>
+            <a:ext cx="73152" cy="1078992"/>
           </a:xfrm>
           <a:prstGeom prst="rect">
             <a:avLst/>
@@ -13094,7 +13126,7 @@
                 </a:solidFill>
                 <a:latin typeface="Aptos"/>
               </a:rPr>
-              <a:t>Gestor/a</a:t>
+              <a:t>Administrador/a de proyecto</a:t>
             </a:r>
           </a:p>
         </p:txBody>
@@ -13108,7 +13140,7 @@
         <p:spPr>
           <a:xfrm>
             <a:off x="841247" y="2441448"/>
-            <a:ext cx="4882896" cy="155448"/>
+            <a:ext cx="4882896" cy="384047"/>
           </a:xfrm>
           <a:prstGeom prst="rect">
             <a:avLst/>
@@ -13129,7 +13161,7 @@
                 </a:solidFill>
                 <a:latin typeface="Aptos"/>
               </a:rPr>
-              <a:t>Planifica iteraciones, recursos, riesgos y comunicación.</a:t>
+              <a:t>Planifica, coordina y supervisa plazos, recursos e hitos.</a:t>
             </a:r>
           </a:p>
         </p:txBody>
@@ -13143,7 +13175,7 @@
         <p:spPr>
           <a:xfrm>
             <a:off x="6172200" y="1874519"/>
-            <a:ext cx="5230368" cy="850392"/>
+            <a:ext cx="5230368" cy="1078992"/>
           </a:xfrm>
           <a:prstGeom prst="roundRect">
             <a:avLst/>
@@ -13188,7 +13220,7 @@
         <p:spPr>
           <a:xfrm>
             <a:off x="6172200" y="1874519"/>
-            <a:ext cx="73152" cy="850392"/>
+            <a:ext cx="73152" cy="1078992"/>
           </a:xfrm>
           <a:prstGeom prst="rect">
             <a:avLst/>
@@ -13266,7 +13298,7 @@
         <p:spPr>
           <a:xfrm>
             <a:off x="6373368" y="2441448"/>
-            <a:ext cx="4882896" cy="155448"/>
+            <a:ext cx="4882896" cy="384047"/>
           </a:xfrm>
           <a:prstGeom prst="rect">
             <a:avLst/>
@@ -13287,7 +13319,7 @@
                 </a:solidFill>
                 <a:latin typeface="Aptos"/>
               </a:rPr>
-              <a:t>Levanta requisitos y mantiene el modelo de casos de uso.</a:t>
+              <a:t>Captura y documenta los requisitos de clientes y administradores.</a:t>
             </a:r>
           </a:p>
         </p:txBody>
@@ -13300,8 +13332,8 @@
         </p:nvSpPr>
         <p:spPr>
           <a:xfrm>
-            <a:off x="640080" y="2926079"/>
-            <a:ext cx="5230368" cy="850392"/>
+            <a:off x="640080" y="3182111"/>
+            <a:ext cx="5230368" cy="1078992"/>
           </a:xfrm>
           <a:prstGeom prst="roundRect">
             <a:avLst/>
@@ -13345,8 +13377,8 @@
         </p:nvSpPr>
         <p:spPr>
           <a:xfrm>
-            <a:off x="640080" y="2926079"/>
-            <a:ext cx="73152" cy="850392"/>
+            <a:off x="640080" y="3182111"/>
+            <a:ext cx="73152" cy="1078992"/>
           </a:xfrm>
           <a:prstGeom prst="rect">
             <a:avLst/>
@@ -13388,7 +13420,7 @@
         </p:nvSpPr>
         <p:spPr>
           <a:xfrm>
-            <a:off x="841247" y="3081527"/>
+            <a:off x="841247" y="3337559"/>
             <a:ext cx="4882896" cy="320040"/>
           </a:xfrm>
           <a:prstGeom prst="rect">
@@ -13410,7 +13442,7 @@
                 </a:solidFill>
                 <a:latin typeface="Aptos"/>
               </a:rPr>
-              <a:t>Arquitecto/a</a:t>
+              <a:t>Diseñador/a</a:t>
             </a:r>
           </a:p>
         </p:txBody>
@@ -13423,8 +13455,8 @@
         </p:nvSpPr>
         <p:spPr>
           <a:xfrm>
-            <a:off x="841247" y="3493008"/>
-            <a:ext cx="4882896" cy="155448"/>
+            <a:off x="841247" y="3749039"/>
+            <a:ext cx="4882896" cy="384047"/>
           </a:xfrm>
           <a:prstGeom prst="rect">
             <a:avLst/>
@@ -13445,7 +13477,7 @@
                 </a:solidFill>
                 <a:latin typeface="Aptos"/>
               </a:rPr>
-              <a:t>Define arquitectura, interfaces y decisiones técnicas.</a:t>
+              <a:t>Crea la arquitectura y los diagramas UML del sistema.</a:t>
             </a:r>
           </a:p>
         </p:txBody>
@@ -13458,8 +13490,8 @@
         </p:nvSpPr>
         <p:spPr>
           <a:xfrm>
-            <a:off x="6172200" y="2926079"/>
-            <a:ext cx="5230368" cy="850392"/>
+            <a:off x="6172200" y="3182111"/>
+            <a:ext cx="5230368" cy="1078992"/>
           </a:xfrm>
           <a:prstGeom prst="roundRect">
             <a:avLst/>
@@ -13503,8 +13535,8 @@
         </p:nvSpPr>
         <p:spPr>
           <a:xfrm>
-            <a:off x="6172200" y="2926079"/>
-            <a:ext cx="73152" cy="850392"/>
+            <a:off x="6172200" y="3182111"/>
+            <a:ext cx="73152" cy="1078992"/>
           </a:xfrm>
           <a:prstGeom prst="rect">
             <a:avLst/>
@@ -13546,7 +13578,7 @@
         </p:nvSpPr>
         <p:spPr>
           <a:xfrm>
-            <a:off x="6373368" y="3081527"/>
+            <a:off x="6373368" y="3337559"/>
             <a:ext cx="4882896" cy="320040"/>
           </a:xfrm>
           <a:prstGeom prst="rect">
@@ -13568,7 +13600,7 @@
                 </a:solidFill>
                 <a:latin typeface="Aptos"/>
               </a:rPr>
-              <a:t>Diseñador/a</a:t>
+              <a:t>Programador/a</a:t>
             </a:r>
           </a:p>
         </p:txBody>
@@ -13581,8 +13613,8 @@
         </p:nvSpPr>
         <p:spPr>
           <a:xfrm>
-            <a:off x="6373368" y="3493008"/>
-            <a:ext cx="4882896" cy="155448"/>
+            <a:off x="6373368" y="3749039"/>
+            <a:ext cx="4882896" cy="384047"/>
           </a:xfrm>
           <a:prstGeom prst="rect">
             <a:avLst/>
@@ -13603,7 +13635,7 @@
                 </a:solidFill>
                 <a:latin typeface="Aptos"/>
               </a:rPr>
-              <a:t>Transforma casos de uso en modelos UML y componentes.</a:t>
+              <a:t>Implementa el código de acceso, compras, stock y boletas.</a:t>
             </a:r>
           </a:p>
         </p:txBody>
@@ -13616,8 +13648,8 @@
         </p:nvSpPr>
         <p:spPr>
           <a:xfrm>
-            <a:off x="640080" y="3977639"/>
-            <a:ext cx="5230368" cy="850392"/>
+            <a:off x="3410712" y="4489704"/>
+            <a:ext cx="5230368" cy="1078992"/>
           </a:xfrm>
           <a:prstGeom prst="roundRect">
             <a:avLst/>
@@ -13661,8 +13693,8 @@
         </p:nvSpPr>
         <p:spPr>
           <a:xfrm>
-            <a:off x="640080" y="3977639"/>
-            <a:ext cx="73152" cy="850392"/>
+            <a:off x="3410712" y="4489704"/>
+            <a:ext cx="73152" cy="1078992"/>
           </a:xfrm>
           <a:prstGeom prst="rect">
             <a:avLst/>
@@ -13704,7 +13736,7 @@
         </p:nvSpPr>
         <p:spPr>
           <a:xfrm>
-            <a:off x="841247" y="4133087"/>
+            <a:off x="3611880" y="4645152"/>
             <a:ext cx="4882896" cy="320040"/>
           </a:xfrm>
           <a:prstGeom prst="rect">
@@ -13726,7 +13758,7 @@
                 </a:solidFill>
                 <a:latin typeface="Aptos"/>
               </a:rPr>
-              <a:t>Desarrollador/a</a:t>
+              <a:t>Tester</a:t>
             </a:r>
           </a:p>
         </p:txBody>
@@ -13739,8 +13771,8 @@
         </p:nvSpPr>
         <p:spPr>
           <a:xfrm>
-            <a:off x="841247" y="4544568"/>
-            <a:ext cx="4882896" cy="155448"/>
+            <a:off x="3611880" y="5056632"/>
+            <a:ext cx="4882896" cy="384047"/>
           </a:xfrm>
           <a:prstGeom prst="rect">
             <a:avLst/>
@@ -13761,7 +13793,7 @@
                 </a:solidFill>
                 <a:latin typeface="Aptos"/>
               </a:rPr>
-              <a:t>Implementa, integra, revisa y documenta el código.</a:t>
+              <a:t>Verifica que el software cumpla los requisitos y criterios.</a:t>
             </a:r>
           </a:p>
         </p:txBody>
@@ -13774,482 +13806,8 @@
         </p:nvSpPr>
         <p:spPr>
           <a:xfrm>
-            <a:off x="6172200" y="3977639"/>
-            <a:ext cx="5230368" cy="850392"/>
-          </a:xfrm>
-          <a:prstGeom prst="roundRect">
-            <a:avLst/>
-          </a:prstGeom>
-          <a:solidFill>
-            <a:srgbClr val="FFFFFF"/>
-          </a:solidFill>
-          <a:ln w="12700">
-            <a:solidFill>
-              <a:srgbClr val="DCD6CC"/>
-            </a:solidFill>
-          </a:ln>
-        </p:spPr>
-        <p:style>
-          <a:lnRef idx="1">
-            <a:schemeClr val="accent1"/>
-          </a:lnRef>
-          <a:fillRef idx="3">
-            <a:schemeClr val="accent1"/>
-          </a:fillRef>
-          <a:effectRef idx="2">
-            <a:schemeClr val="accent1"/>
-          </a:effectRef>
-          <a:fontRef idx="minor">
-            <a:schemeClr val="lt1"/>
-          </a:fontRef>
-        </p:style>
-        <p:txBody>
-          <a:bodyPr rtlCol="0" anchor="ctr"/>
-          <a:lstStyle/>
-          <a:p>
-            <a:pPr algn="ctr"/>
-          </a:p>
-        </p:txBody>
-      </p:sp>
-      <p:sp>
-        <p:nvSpPr>
-          <p:cNvPr id="29" name="Rectangle 28"/>
-          <p:cNvSpPr/>
-          <p:nvPr/>
-        </p:nvSpPr>
-        <p:spPr>
-          <a:xfrm>
-            <a:off x="6172200" y="3977639"/>
-            <a:ext cx="73152" cy="850392"/>
-          </a:xfrm>
-          <a:prstGeom prst="rect">
-            <a:avLst/>
-          </a:prstGeom>
-          <a:solidFill>
-            <a:srgbClr val="2E6958"/>
-          </a:solidFill>
-          <a:ln>
-            <a:noFill/>
-          </a:ln>
-        </p:spPr>
-        <p:style>
-          <a:lnRef idx="1">
-            <a:schemeClr val="accent1"/>
-          </a:lnRef>
-          <a:fillRef idx="3">
-            <a:schemeClr val="accent1"/>
-          </a:fillRef>
-          <a:effectRef idx="2">
-            <a:schemeClr val="accent1"/>
-          </a:effectRef>
-          <a:fontRef idx="minor">
-            <a:schemeClr val="lt1"/>
-          </a:fontRef>
-        </p:style>
-        <p:txBody>
-          <a:bodyPr rtlCol="0" anchor="ctr"/>
-          <a:lstStyle/>
-          <a:p>
-            <a:pPr algn="ctr"/>
-          </a:p>
-        </p:txBody>
-      </p:sp>
-      <p:sp>
-        <p:nvSpPr>
-          <p:cNvPr id="30" name="TextBox 29"/>
-          <p:cNvSpPr txBox="1"/>
-          <p:nvPr/>
-        </p:nvSpPr>
-        <p:spPr>
-          <a:xfrm>
-            <a:off x="6373368" y="4133087"/>
-            <a:ext cx="4882896" cy="320040"/>
-          </a:xfrm>
-          <a:prstGeom prst="rect">
-            <a:avLst/>
-          </a:prstGeom>
-          <a:noFill/>
-        </p:spPr>
-        <p:txBody>
-          <a:bodyPr wrap="square" lIns="54864" rIns="54864" tIns="54864" bIns="54864" anchor="t">
-            <a:spAutoFit/>
-          </a:bodyPr>
-          <a:lstStyle/>
-          <a:p>
-            <a:pPr algn="l"/>
-            <a:r>
-              <a:rPr sz="1400" b="1">
-                <a:solidFill>
-                  <a:srgbClr val="2E6958"/>
-                </a:solidFill>
-                <a:latin typeface="Aptos"/>
-              </a:rPr>
-              <a:t>Tester</a:t>
-            </a:r>
-          </a:p>
-        </p:txBody>
-      </p:sp>
-      <p:sp>
-        <p:nvSpPr>
-          <p:cNvPr id="31" name="TextBox 30"/>
-          <p:cNvSpPr txBox="1"/>
-          <p:nvPr/>
-        </p:nvSpPr>
-        <p:spPr>
-          <a:xfrm>
-            <a:off x="6373368" y="4544568"/>
-            <a:ext cx="4882896" cy="155448"/>
-          </a:xfrm>
-          <a:prstGeom prst="rect">
-            <a:avLst/>
-          </a:prstGeom>
-          <a:noFill/>
-        </p:spPr>
-        <p:txBody>
-          <a:bodyPr wrap="square" lIns="54864" rIns="54864" tIns="54864" bIns="54864" anchor="t">
-            <a:spAutoFit/>
-          </a:bodyPr>
-          <a:lstStyle/>
-          <a:p>
-            <a:pPr algn="l"/>
-            <a:r>
-              <a:rPr sz="1200" b="0">
-                <a:solidFill>
-                  <a:srgbClr val="2B2A26"/>
-                </a:solidFill>
-                <a:latin typeface="Aptos"/>
-              </a:rPr>
-              <a:t>Diseña pruebas, verifica criterios y registra desviaciones.</a:t>
-            </a:r>
-          </a:p>
-        </p:txBody>
-      </p:sp>
-      <p:sp>
-        <p:nvSpPr>
-          <p:cNvPr id="32" name="Rounded Rectangle 31"/>
-          <p:cNvSpPr/>
-          <p:nvPr/>
-        </p:nvSpPr>
-        <p:spPr>
-          <a:xfrm>
-            <a:off x="640080" y="5029200"/>
-            <a:ext cx="5230368" cy="850392"/>
-          </a:xfrm>
-          <a:prstGeom prst="roundRect">
-            <a:avLst/>
-          </a:prstGeom>
-          <a:solidFill>
-            <a:srgbClr val="FFFFFF"/>
-          </a:solidFill>
-          <a:ln w="12700">
-            <a:solidFill>
-              <a:srgbClr val="DCD6CC"/>
-            </a:solidFill>
-          </a:ln>
-        </p:spPr>
-        <p:style>
-          <a:lnRef idx="1">
-            <a:schemeClr val="accent1"/>
-          </a:lnRef>
-          <a:fillRef idx="3">
-            <a:schemeClr val="accent1"/>
-          </a:fillRef>
-          <a:effectRef idx="2">
-            <a:schemeClr val="accent1"/>
-          </a:effectRef>
-          <a:fontRef idx="minor">
-            <a:schemeClr val="lt1"/>
-          </a:fontRef>
-        </p:style>
-        <p:txBody>
-          <a:bodyPr rtlCol="0" anchor="ctr"/>
-          <a:lstStyle/>
-          <a:p>
-            <a:pPr algn="ctr"/>
-          </a:p>
-        </p:txBody>
-      </p:sp>
-      <p:sp>
-        <p:nvSpPr>
-          <p:cNvPr id="33" name="Rectangle 32"/>
-          <p:cNvSpPr/>
-          <p:nvPr/>
-        </p:nvSpPr>
-        <p:spPr>
-          <a:xfrm>
-            <a:off x="640080" y="5029200"/>
-            <a:ext cx="73152" cy="850392"/>
-          </a:xfrm>
-          <a:prstGeom prst="rect">
-            <a:avLst/>
-          </a:prstGeom>
-          <a:solidFill>
-            <a:srgbClr val="664330"/>
-          </a:solidFill>
-          <a:ln>
-            <a:noFill/>
-          </a:ln>
-        </p:spPr>
-        <p:style>
-          <a:lnRef idx="1">
-            <a:schemeClr val="accent1"/>
-          </a:lnRef>
-          <a:fillRef idx="3">
-            <a:schemeClr val="accent1"/>
-          </a:fillRef>
-          <a:effectRef idx="2">
-            <a:schemeClr val="accent1"/>
-          </a:effectRef>
-          <a:fontRef idx="minor">
-            <a:schemeClr val="lt1"/>
-          </a:fontRef>
-        </p:style>
-        <p:txBody>
-          <a:bodyPr rtlCol="0" anchor="ctr"/>
-          <a:lstStyle/>
-          <a:p>
-            <a:pPr algn="ctr"/>
-          </a:p>
-        </p:txBody>
-      </p:sp>
-      <p:sp>
-        <p:nvSpPr>
-          <p:cNvPr id="34" name="TextBox 33"/>
-          <p:cNvSpPr txBox="1"/>
-          <p:nvPr/>
-        </p:nvSpPr>
-        <p:spPr>
-          <a:xfrm>
-            <a:off x="841247" y="5184648"/>
-            <a:ext cx="4882896" cy="320040"/>
-          </a:xfrm>
-          <a:prstGeom prst="rect">
-            <a:avLst/>
-          </a:prstGeom>
-          <a:noFill/>
-        </p:spPr>
-        <p:txBody>
-          <a:bodyPr wrap="square" lIns="54864" rIns="54864" tIns="54864" bIns="54864" anchor="t">
-            <a:spAutoFit/>
-          </a:bodyPr>
-          <a:lstStyle/>
-          <a:p>
-            <a:pPr algn="l"/>
-            <a:r>
-              <a:rPr sz="1400" b="1">
-                <a:solidFill>
-                  <a:srgbClr val="664330"/>
-                </a:solidFill>
-                <a:latin typeface="Aptos"/>
-              </a:rPr>
-              <a:t>Config. y cambios</a:t>
-            </a:r>
-          </a:p>
-        </p:txBody>
-      </p:sp>
-      <p:sp>
-        <p:nvSpPr>
-          <p:cNvPr id="35" name="TextBox 34"/>
-          <p:cNvSpPr txBox="1"/>
-          <p:nvPr/>
-        </p:nvSpPr>
-        <p:spPr>
-          <a:xfrm>
-            <a:off x="841247" y="5596128"/>
-            <a:ext cx="4882896" cy="155448"/>
-          </a:xfrm>
-          <a:prstGeom prst="rect">
-            <a:avLst/>
-          </a:prstGeom>
-          <a:noFill/>
-        </p:spPr>
-        <p:txBody>
-          <a:bodyPr wrap="square" lIns="54864" rIns="54864" tIns="54864" bIns="54864" anchor="t">
-            <a:spAutoFit/>
-          </a:bodyPr>
-          <a:lstStyle/>
-          <a:p>
-            <a:pPr algn="l"/>
-            <a:r>
-              <a:rPr sz="1200" b="0">
-                <a:solidFill>
-                  <a:srgbClr val="2B2A26"/>
-                </a:solidFill>
-                <a:latin typeface="Aptos"/>
-              </a:rPr>
-              <a:t>Versiona artefactos, líneas base y solicitudes.</a:t>
-            </a:r>
-          </a:p>
-        </p:txBody>
-      </p:sp>
-      <p:sp>
-        <p:nvSpPr>
-          <p:cNvPr id="36" name="Rounded Rectangle 35"/>
-          <p:cNvSpPr/>
-          <p:nvPr/>
-        </p:nvSpPr>
-        <p:spPr>
-          <a:xfrm>
-            <a:off x="6172200" y="5029200"/>
-            <a:ext cx="5230368" cy="850392"/>
-          </a:xfrm>
-          <a:prstGeom prst="roundRect">
-            <a:avLst/>
-          </a:prstGeom>
-          <a:solidFill>
-            <a:srgbClr val="FFFFFF"/>
-          </a:solidFill>
-          <a:ln w="12700">
-            <a:solidFill>
-              <a:srgbClr val="DCD6CC"/>
-            </a:solidFill>
-          </a:ln>
-        </p:spPr>
-        <p:style>
-          <a:lnRef idx="1">
-            <a:schemeClr val="accent1"/>
-          </a:lnRef>
-          <a:fillRef idx="3">
-            <a:schemeClr val="accent1"/>
-          </a:fillRef>
-          <a:effectRef idx="2">
-            <a:schemeClr val="accent1"/>
-          </a:effectRef>
-          <a:fontRef idx="minor">
-            <a:schemeClr val="lt1"/>
-          </a:fontRef>
-        </p:style>
-        <p:txBody>
-          <a:bodyPr rtlCol="0" anchor="ctr"/>
-          <a:lstStyle/>
-          <a:p>
-            <a:pPr algn="ctr"/>
-          </a:p>
-        </p:txBody>
-      </p:sp>
-      <p:sp>
-        <p:nvSpPr>
-          <p:cNvPr id="37" name="Rectangle 36"/>
-          <p:cNvSpPr/>
-          <p:nvPr/>
-        </p:nvSpPr>
-        <p:spPr>
-          <a:xfrm>
-            <a:off x="6172200" y="5029200"/>
-            <a:ext cx="73152" cy="850392"/>
-          </a:xfrm>
-          <a:prstGeom prst="rect">
-            <a:avLst/>
-          </a:prstGeom>
-          <a:solidFill>
-            <a:srgbClr val="DAA64E"/>
-          </a:solidFill>
-          <a:ln>
-            <a:noFill/>
-          </a:ln>
-        </p:spPr>
-        <p:style>
-          <a:lnRef idx="1">
-            <a:schemeClr val="accent1"/>
-          </a:lnRef>
-          <a:fillRef idx="3">
-            <a:schemeClr val="accent1"/>
-          </a:fillRef>
-          <a:effectRef idx="2">
-            <a:schemeClr val="accent1"/>
-          </a:effectRef>
-          <a:fontRef idx="minor">
-            <a:schemeClr val="lt1"/>
-          </a:fontRef>
-        </p:style>
-        <p:txBody>
-          <a:bodyPr rtlCol="0" anchor="ctr"/>
-          <a:lstStyle/>
-          <a:p>
-            <a:pPr algn="ctr"/>
-          </a:p>
-        </p:txBody>
-      </p:sp>
-      <p:sp>
-        <p:nvSpPr>
-          <p:cNvPr id="38" name="TextBox 37"/>
-          <p:cNvSpPr txBox="1"/>
-          <p:nvPr/>
-        </p:nvSpPr>
-        <p:spPr>
-          <a:xfrm>
-            <a:off x="6373368" y="5184648"/>
-            <a:ext cx="4882896" cy="320040"/>
-          </a:xfrm>
-          <a:prstGeom prst="rect">
-            <a:avLst/>
-          </a:prstGeom>
-          <a:noFill/>
-        </p:spPr>
-        <p:txBody>
-          <a:bodyPr wrap="square" lIns="54864" rIns="54864" tIns="54864" bIns="54864" anchor="t">
-            <a:spAutoFit/>
-          </a:bodyPr>
-          <a:lstStyle/>
-          <a:p>
-            <a:pPr algn="l"/>
-            <a:r>
-              <a:rPr sz="1400" b="1">
-                <a:solidFill>
-                  <a:srgbClr val="DAA64E"/>
-                </a:solidFill>
-                <a:latin typeface="Aptos"/>
-              </a:rPr>
-              <a:t>Cliente</a:t>
-            </a:r>
-          </a:p>
-        </p:txBody>
-      </p:sp>
-      <p:sp>
-        <p:nvSpPr>
-          <p:cNvPr id="39" name="TextBox 38"/>
-          <p:cNvSpPr txBox="1"/>
-          <p:nvPr/>
-        </p:nvSpPr>
-        <p:spPr>
-          <a:xfrm>
-            <a:off x="6373368" y="5596128"/>
-            <a:ext cx="4882896" cy="155448"/>
-          </a:xfrm>
-          <a:prstGeom prst="rect">
-            <a:avLst/>
-          </a:prstGeom>
-          <a:noFill/>
-        </p:spPr>
-        <p:txBody>
-          <a:bodyPr wrap="square" lIns="54864" rIns="54864" tIns="54864" bIns="54864" anchor="t">
-            <a:spAutoFit/>
-          </a:bodyPr>
-          <a:lstStyle/>
-          <a:p>
-            <a:pPr algn="l"/>
-            <a:r>
-              <a:rPr sz="1200" b="0">
-                <a:solidFill>
-                  <a:srgbClr val="2B2A26"/>
-                </a:solidFill>
-                <a:latin typeface="Aptos"/>
-              </a:rPr>
-              <a:t>Prioriza valor, aclara reglas y acepta cada incremento.</a:t>
-            </a:r>
-          </a:p>
-        </p:txBody>
-      </p:sp>
-      <p:sp>
-        <p:nvSpPr>
-          <p:cNvPr id="40" name="Rounded Rectangle 39"/>
-          <p:cNvSpPr/>
-          <p:nvPr/>
-        </p:nvSpPr>
-        <p:spPr>
-          <a:xfrm>
-            <a:off x="640080" y="6099048"/>
-            <a:ext cx="10762488" cy="256032"/>
+            <a:off x="640080" y="5870448"/>
+            <a:ext cx="10762488" cy="393192"/>
           </a:xfrm>
           <a:prstGeom prst="roundRect">
             <a:avLst/>
@@ -14287,14 +13845,14 @@
       </p:sp>
       <p:sp>
         <p:nvSpPr>
-          <p:cNvPr id="41" name="TextBox 40"/>
-          <p:cNvSpPr txBox="1"/>
-          <p:nvPr/>
-        </p:nvSpPr>
-        <p:spPr>
-          <a:xfrm>
-            <a:off x="841248" y="6117336"/>
-            <a:ext cx="10332720" cy="182880"/>
+          <p:cNvPr id="29" name="TextBox 28"/>
+          <p:cNvSpPr txBox="1"/>
+          <p:nvPr/>
+        </p:nvSpPr>
+        <p:spPr>
+          <a:xfrm>
+            <a:off x="841248" y="5943600"/>
+            <a:ext cx="10332720" cy="219456"/>
           </a:xfrm>
           <a:prstGeom prst="rect">
             <a:avLst/>
@@ -14315,7 +13873,7 @@
                 </a:solidFill>
                 <a:latin typeface="Aptos"/>
               </a:rPr>
-              <a:t>Regla: nadie modifica una línea base sin registrar, analizar y aprobar el cambio.</a:t>
+              <a:t>Los casos de uso coordinan el trabajo: cada rol actualiza sus artefactos cuando cambia un requisito.</a:t>
             </a:r>
           </a:p>
         </p:txBody>
@@ -14709,7 +14267,7 @@
                 </a:solidFill>
                 <a:latin typeface="Aptos"/>
               </a:rPr>
-              <a:t>Acordar visión, alcance, actores, casos de uso prioritarios y riesgos iniciales.</a:t>
+              <a:t>Levantar requisitos, definir alcance, realizar la planificación inicial y estimar costos.</a:t>
             </a:r>
           </a:p>
         </p:txBody>
@@ -14787,7 +14345,7 @@
                 </a:solidFill>
                 <a:latin typeface="Aptos"/>
               </a:rPr>
-              <a:t>Hito: objetivos aceptados</a:t>
+              <a:t>Artefactos: casos de uso y visión</a:t>
             </a:r>
           </a:p>
         </p:txBody>
@@ -14937,7 +14495,7 @@
                 </a:solidFill>
                 <a:latin typeface="Aptos"/>
               </a:rPr>
-              <a:t>Refinar requisitos y validar una arquitectura ejecutable mediante modelos UML.</a:t>
+              <a:t>Analizar y diseñar, validar la arquitectura, planificar iteraciones y gestionar riesgos.</a:t>
             </a:r>
           </a:p>
         </p:txBody>
@@ -15015,7 +14573,7 @@
                 </a:solidFill>
                 <a:latin typeface="Aptos"/>
               </a:rPr>
-              <a:t>Hito: arquitectura estable</a:t>
+              <a:t>Artefactos: UML y prototipos</a:t>
             </a:r>
           </a:p>
         </p:txBody>
@@ -15165,7 +14723,7 @@
                 </a:solidFill>
                 <a:latin typeface="Aptos"/>
               </a:rPr>
-              <a:t>Implementar e integrar los casos de uso, con pruebas continuas y documentación.</a:t>
+              <a:t>Implementar, integrar y ejecutar pruebas unitarias e iterativas con revisiones de avance.</a:t>
             </a:r>
           </a:p>
         </p:txBody>
@@ -15243,7 +14801,7 @@
                 </a:solidFill>
                 <a:latin typeface="Aptos"/>
               </a:rPr>
-              <a:t>Hito: incremento operable</a:t>
+              <a:t>Artefactos: código y manual técnico</a:t>
             </a:r>
           </a:p>
         </p:txBody>
@@ -15393,7 +14951,7 @@
                 </a:solidFill>
                 <a:latin typeface="Aptos"/>
               </a:rPr>
-              <a:t>Probar con usuarios, desplegar, capacitar y recoger desviaciones para la siguiente iteración.</a:t>
+              <a:t>Realizar pruebas finales, desplegar, capacitar usuarios y estabilizar el sistema.</a:t>
             </a:r>
           </a:p>
         </p:txBody>
@@ -15471,7 +15029,7 @@
                 </a:solidFill>
                 <a:latin typeface="Aptos"/>
               </a:rPr>
-              <a:t>Hito: incremento aceptado</a:t>
+              <a:t>Artefactos: plan y manual de usuario</a:t>
             </a:r>
           </a:p>
         </p:txBody>

</xml_diff>

<commit_message>
Integrar tablas oficiales en presentación final
Co-authored-by: TheXKnight117 <TheXKnight117@users.noreply.github.com>
</commit_message>
<xml_diff>
--- a/Presentacion_Dolce_Vita_Proceso_Unificado.pptx
+++ b/Presentacion_Dolce_Vita_Proceso_Unificado.pptx
@@ -3313,8 +3313,8 @@
         </p:nvSpPr>
         <p:spPr>
           <a:xfrm>
-            <a:off x="914400" y="4178808"/>
-            <a:ext cx="4846320" cy="713232"/>
+            <a:off x="914400" y="4251960"/>
+            <a:ext cx="4846320" cy="475488"/>
           </a:xfrm>
           <a:prstGeom prst="rect">
             <a:avLst/>
@@ -3335,9 +3335,8 @@
                 </a:solidFill>
                 <a:latin typeface="Aptos"/>
               </a:rPr>
-              <a:t>Integrantes: [Nombre 1] · [Nombre 2] · [Nombre 3]
-Asignatura: Diseño de Software  |  Docente: [Nombre]
-Sección: [Sección]  |  Fecha: [Fecha]</a:t>
+              <a:t>Integrante: Cristopher Alexander Bañares Suarez
+Asignatura: Diseño de Software</a:t>
             </a:r>
           </a:p>
         </p:txBody>
@@ -12855,7 +12854,7 @@
                 </a:solidFill>
                 <a:latin typeface="Aptos"/>
               </a:rPr>
-              <a:t>Roles y responsabilidades</a:t>
+              <a:t>Tabla de roles aplicada a Dolce‑Vita</a:t>
             </a:r>
           </a:p>
         </p:txBody>
@@ -12890,7 +12889,7 @@
                 </a:solidFill>
                 <a:latin typeface="Aptos"/>
               </a:rPr>
-              <a:t>Responsabilidades alineadas con la Tabla de Roles del material de la asignatura.</a:t>
+              <a:t>La asignación explícita de responsabilidades evita vacíos y duplicidad de trabajo.</a:t>
             </a:r>
           </a:p>
         </p:txBody>
@@ -13008,806 +13007,541 @@
           </a:p>
         </p:txBody>
       </p:sp>
-      <p:sp>
-        <p:nvSpPr>
-          <p:cNvPr id="8" name="Rounded Rectangle 7"/>
+      <p:graphicFrame>
+        <p:nvGraphicFramePr>
+          <p:cNvPr id="8" name="Table 7"/>
+          <p:cNvGraphicFramePr>
+            <a:graphicFrameLocks noGrp="1"/>
+          </p:cNvGraphicFramePr>
+          <p:nvPr/>
+        </p:nvGraphicFramePr>
+        <p:xfrm>
+          <a:off x="566928" y="1828800"/>
+          <a:ext cx="11045952" cy="4059936"/>
+        </p:xfrm>
+        <a:graphic>
+          <a:graphicData uri="http://schemas.openxmlformats.org/drawingml/2006/table">
+            <a:tbl>
+              <a:tblPr firstRow="1" bandRow="1">
+                <a:tableStyleId>{5C22544A-7EE6-4342-B048-85BDC9FD1C3A}</a:tableStyleId>
+              </a:tblPr>
+              <a:tblGrid>
+                <a:gridCol w="2121408"/>
+                <a:gridCol w="3794760"/>
+                <a:gridCol w="5129784"/>
+              </a:tblGrid>
+              <a:tr h="676656">
+                <a:tc>
+                  <a:txBody>
+                    <a:bodyPr/>
+                    <a:lstStyle/>
+                    <a:p>
+                      <a:pPr>
+                        <a:spcAft>
+                          <a:spcPts val="0"/>
+                        </a:spcAft>
+                      </a:pPr>
+                      <a:r>
+                        <a:rPr sz="1040" b="1">
+                          <a:solidFill>
+                            <a:srgbClr val="FFFFFF"/>
+                          </a:solidFill>
+                          <a:latin typeface="Aptos"/>
+                        </a:rPr>
+                        <a:t>Rol</a:t>
+                      </a:r>
+                    </a:p>
+                  </a:txBody>
+                  <a:tcPr marL="64008" marR="64008" marT="45720" marB="36576">
+                    <a:solidFill>
+                      <a:srgbClr val="664330"/>
+                    </a:solidFill>
+                  </a:tcPr>
+                </a:tc>
+                <a:tc>
+                  <a:txBody>
+                    <a:bodyPr/>
+                    <a:lstStyle/>
+                    <a:p>
+                      <a:pPr>
+                        <a:spcAft>
+                          <a:spcPts val="0"/>
+                        </a:spcAft>
+                      </a:pPr>
+                      <a:r>
+                        <a:rPr sz="1040" b="1">
+                          <a:solidFill>
+                            <a:srgbClr val="FFFFFF"/>
+                          </a:solidFill>
+                          <a:latin typeface="Aptos"/>
+                        </a:rPr>
+                        <a:t>Responsabilidad principal</a:t>
+                      </a:r>
+                    </a:p>
+                  </a:txBody>
+                  <a:tcPr marL="64008" marR="64008" marT="45720" marB="36576">
+                    <a:solidFill>
+                      <a:srgbClr val="664330"/>
+                    </a:solidFill>
+                  </a:tcPr>
+                </a:tc>
+                <a:tc>
+                  <a:txBody>
+                    <a:bodyPr/>
+                    <a:lstStyle/>
+                    <a:p>
+                      <a:pPr>
+                        <a:spcAft>
+                          <a:spcPts val="0"/>
+                        </a:spcAft>
+                      </a:pPr>
+                      <a:r>
+                        <a:rPr sz="1040" b="1">
+                          <a:solidFill>
+                            <a:srgbClr val="FFFFFF"/>
+                          </a:solidFill>
+                          <a:latin typeface="Aptos"/>
+                        </a:rPr>
+                        <a:t>Aplicación en Dolce‑Vita</a:t>
+                      </a:r>
+                    </a:p>
+                  </a:txBody>
+                  <a:tcPr marL="64008" marR="64008" marT="45720" marB="36576">
+                    <a:solidFill>
+                      <a:srgbClr val="664330"/>
+                    </a:solidFill>
+                  </a:tcPr>
+                </a:tc>
+              </a:tr>
+              <a:tr h="676656">
+                <a:tc>
+                  <a:txBody>
+                    <a:bodyPr/>
+                    <a:lstStyle/>
+                    <a:p>
+                      <a:pPr>
+                        <a:spcAft>
+                          <a:spcPts val="0"/>
+                        </a:spcAft>
+                      </a:pPr>
+                      <a:r>
+                        <a:rPr sz="1090" b="1">
+                          <a:solidFill>
+                            <a:srgbClr val="2B2A26"/>
+                          </a:solidFill>
+                          <a:latin typeface="Aptos"/>
+                        </a:rPr>
+                        <a:t>Analista</a:t>
+                      </a:r>
+                    </a:p>
+                  </a:txBody>
+                  <a:tcPr marL="64008" marR="64008" marT="45720" marB="36576">
+                    <a:solidFill>
+                      <a:srgbClr val="FFFFFF"/>
+                    </a:solidFill>
+                  </a:tcPr>
+                </a:tc>
+                <a:tc>
+                  <a:txBody>
+                    <a:bodyPr/>
+                    <a:lstStyle/>
+                    <a:p>
+                      <a:pPr>
+                        <a:spcAft>
+                          <a:spcPts val="0"/>
+                        </a:spcAft>
+                      </a:pPr>
+                      <a:r>
+                        <a:rPr sz="1090" b="0">
+                          <a:solidFill>
+                            <a:srgbClr val="2B2A26"/>
+                          </a:solidFill>
+                          <a:latin typeface="Aptos"/>
+                        </a:rPr>
+                        <a:t>Captura y documenta requerimientos.</a:t>
+                      </a:r>
+                    </a:p>
+                  </a:txBody>
+                  <a:tcPr marL="64008" marR="64008" marT="45720" marB="36576">
+                    <a:solidFill>
+                      <a:srgbClr val="FFFFFF"/>
+                    </a:solidFill>
+                  </a:tcPr>
+                </a:tc>
+                <a:tc>
+                  <a:txBody>
+                    <a:bodyPr/>
+                    <a:lstStyle/>
+                    <a:p>
+                      <a:pPr>
+                        <a:spcAft>
+                          <a:spcPts val="0"/>
+                        </a:spcAft>
+                      </a:pPr>
+                      <a:r>
+                        <a:rPr sz="1090" b="0">
+                          <a:solidFill>
+                            <a:srgbClr val="2B2A26"/>
+                          </a:solidFill>
+                          <a:latin typeface="Aptos"/>
+                        </a:rPr>
+                        <a:t>Define reglas de registro, compra, stock, alertas y boleta.</a:t>
+                      </a:r>
+                    </a:p>
+                  </a:txBody>
+                  <a:tcPr marL="64008" marR="64008" marT="45720" marB="36576">
+                    <a:solidFill>
+                      <a:srgbClr val="FFFFFF"/>
+                    </a:solidFill>
+                  </a:tcPr>
+                </a:tc>
+              </a:tr>
+              <a:tr h="676656">
+                <a:tc>
+                  <a:txBody>
+                    <a:bodyPr/>
+                    <a:lstStyle/>
+                    <a:p>
+                      <a:pPr>
+                        <a:spcAft>
+                          <a:spcPts val="0"/>
+                        </a:spcAft>
+                      </a:pPr>
+                      <a:r>
+                        <a:rPr sz="1090" b="1">
+                          <a:solidFill>
+                            <a:srgbClr val="2B2A26"/>
+                          </a:solidFill>
+                          <a:latin typeface="Aptos"/>
+                        </a:rPr>
+                        <a:t>Diseñador/a</a:t>
+                      </a:r>
+                    </a:p>
+                  </a:txBody>
+                  <a:tcPr marL="64008" marR="64008" marT="45720" marB="36576">
+                    <a:solidFill>
+                      <a:srgbClr val="F4F1EB"/>
+                    </a:solidFill>
+                  </a:tcPr>
+                </a:tc>
+                <a:tc>
+                  <a:txBody>
+                    <a:bodyPr/>
+                    <a:lstStyle/>
+                    <a:p>
+                      <a:pPr>
+                        <a:spcAft>
+                          <a:spcPts val="0"/>
+                        </a:spcAft>
+                      </a:pPr>
+                      <a:r>
+                        <a:rPr sz="1090" b="0">
+                          <a:solidFill>
+                            <a:srgbClr val="2B2A26"/>
+                          </a:solidFill>
+                          <a:latin typeface="Aptos"/>
+                        </a:rPr>
+                        <a:t>Crea la arquitectura y los diagramas UML.</a:t>
+                      </a:r>
+                    </a:p>
+                  </a:txBody>
+                  <a:tcPr marL="64008" marR="64008" marT="45720" marB="36576">
+                    <a:solidFill>
+                      <a:srgbClr val="F4F1EB"/>
+                    </a:solidFill>
+                  </a:tcPr>
+                </a:tc>
+                <a:tc>
+                  <a:txBody>
+                    <a:bodyPr/>
+                    <a:lstStyle/>
+                    <a:p>
+                      <a:pPr>
+                        <a:spcAft>
+                          <a:spcPts val="0"/>
+                        </a:spcAft>
+                      </a:pPr>
+                      <a:r>
+                        <a:rPr sz="1090" b="0">
+                          <a:solidFill>
+                            <a:srgbClr val="2B2A26"/>
+                          </a:solidFill>
+                          <a:latin typeface="Aptos"/>
+                        </a:rPr>
+                        <a:t>Modela usuarios, productos, carro, inventario y ventas.</a:t>
+                      </a:r>
+                    </a:p>
+                  </a:txBody>
+                  <a:tcPr marL="64008" marR="64008" marT="45720" marB="36576">
+                    <a:solidFill>
+                      <a:srgbClr val="F4F1EB"/>
+                    </a:solidFill>
+                  </a:tcPr>
+                </a:tc>
+              </a:tr>
+              <a:tr h="676656">
+                <a:tc>
+                  <a:txBody>
+                    <a:bodyPr/>
+                    <a:lstStyle/>
+                    <a:p>
+                      <a:pPr>
+                        <a:spcAft>
+                          <a:spcPts val="0"/>
+                        </a:spcAft>
+                      </a:pPr>
+                      <a:r>
+                        <a:rPr sz="1090" b="1">
+                          <a:solidFill>
+                            <a:srgbClr val="2B2A26"/>
+                          </a:solidFill>
+                          <a:latin typeface="Aptos"/>
+                        </a:rPr>
+                        <a:t>Programador/a</a:t>
+                      </a:r>
+                    </a:p>
+                  </a:txBody>
+                  <a:tcPr marL="64008" marR="64008" marT="45720" marB="36576">
+                    <a:solidFill>
+                      <a:srgbClr val="FFFFFF"/>
+                    </a:solidFill>
+                  </a:tcPr>
+                </a:tc>
+                <a:tc>
+                  <a:txBody>
+                    <a:bodyPr/>
+                    <a:lstStyle/>
+                    <a:p>
+                      <a:pPr>
+                        <a:spcAft>
+                          <a:spcPts val="0"/>
+                        </a:spcAft>
+                      </a:pPr>
+                      <a:r>
+                        <a:rPr sz="1090" b="0">
+                          <a:solidFill>
+                            <a:srgbClr val="2B2A26"/>
+                          </a:solidFill>
+                          <a:latin typeface="Aptos"/>
+                        </a:rPr>
+                        <a:t>Implementa el código del sistema.</a:t>
+                      </a:r>
+                    </a:p>
+                  </a:txBody>
+                  <a:tcPr marL="64008" marR="64008" marT="45720" marB="36576">
+                    <a:solidFill>
+                      <a:srgbClr val="FFFFFF"/>
+                    </a:solidFill>
+                  </a:tcPr>
+                </a:tc>
+                <a:tc>
+                  <a:txBody>
+                    <a:bodyPr/>
+                    <a:lstStyle/>
+                    <a:p>
+                      <a:pPr>
+                        <a:spcAft>
+                          <a:spcPts val="0"/>
+                        </a:spcAft>
+                      </a:pPr>
+                      <a:r>
+                        <a:rPr sz="1090" b="0">
+                          <a:solidFill>
+                            <a:srgbClr val="2B2A26"/>
+                          </a:solidFill>
+                          <a:latin typeface="Aptos"/>
+                        </a:rPr>
+                        <a:t>Programa los módulos de acceso, compra, stock y boleta.</a:t>
+                      </a:r>
+                    </a:p>
+                  </a:txBody>
+                  <a:tcPr marL="64008" marR="64008" marT="45720" marB="36576">
+                    <a:solidFill>
+                      <a:srgbClr val="FFFFFF"/>
+                    </a:solidFill>
+                  </a:tcPr>
+                </a:tc>
+              </a:tr>
+              <a:tr h="676656">
+                <a:tc>
+                  <a:txBody>
+                    <a:bodyPr/>
+                    <a:lstStyle/>
+                    <a:p>
+                      <a:pPr>
+                        <a:spcAft>
+                          <a:spcPts val="0"/>
+                        </a:spcAft>
+                      </a:pPr>
+                      <a:r>
+                        <a:rPr sz="1090" b="1">
+                          <a:solidFill>
+                            <a:srgbClr val="2B2A26"/>
+                          </a:solidFill>
+                          <a:latin typeface="Aptos"/>
+                        </a:rPr>
+                        <a:t>Tester</a:t>
+                      </a:r>
+                    </a:p>
+                  </a:txBody>
+                  <a:tcPr marL="64008" marR="64008" marT="45720" marB="36576">
+                    <a:solidFill>
+                      <a:srgbClr val="F4F1EB"/>
+                    </a:solidFill>
+                  </a:tcPr>
+                </a:tc>
+                <a:tc>
+                  <a:txBody>
+                    <a:bodyPr/>
+                    <a:lstStyle/>
+                    <a:p>
+                      <a:pPr>
+                        <a:spcAft>
+                          <a:spcPts val="0"/>
+                        </a:spcAft>
+                      </a:pPr>
+                      <a:r>
+                        <a:rPr sz="1090" b="0">
+                          <a:solidFill>
+                            <a:srgbClr val="2B2A26"/>
+                          </a:solidFill>
+                          <a:latin typeface="Aptos"/>
+                        </a:rPr>
+                        <a:t>Verifica que el software cumpla los requisitos.</a:t>
+                      </a:r>
+                    </a:p>
+                  </a:txBody>
+                  <a:tcPr marL="64008" marR="64008" marT="45720" marB="36576">
+                    <a:solidFill>
+                      <a:srgbClr val="F4F1EB"/>
+                    </a:solidFill>
+                  </a:tcPr>
+                </a:tc>
+                <a:tc>
+                  <a:txBody>
+                    <a:bodyPr/>
+                    <a:lstStyle/>
+                    <a:p>
+                      <a:pPr>
+                        <a:spcAft>
+                          <a:spcPts val="0"/>
+                        </a:spcAft>
+                      </a:pPr>
+                      <a:r>
+                        <a:rPr sz="1090" b="0">
+                          <a:solidFill>
+                            <a:srgbClr val="2B2A26"/>
+                          </a:solidFill>
+                          <a:latin typeface="Aptos"/>
+                        </a:rPr>
+                        <a:t>Prueba flujos de compra, inventario, alertas y emisión de boleta.</a:t>
+                      </a:r>
+                    </a:p>
+                  </a:txBody>
+                  <a:tcPr marL="64008" marR="64008" marT="45720" marB="36576">
+                    <a:solidFill>
+                      <a:srgbClr val="F4F1EB"/>
+                    </a:solidFill>
+                  </a:tcPr>
+                </a:tc>
+              </a:tr>
+              <a:tr h="676656">
+                <a:tc>
+                  <a:txBody>
+                    <a:bodyPr/>
+                    <a:lstStyle/>
+                    <a:p>
+                      <a:pPr>
+                        <a:spcAft>
+                          <a:spcPts val="0"/>
+                        </a:spcAft>
+                      </a:pPr>
+                      <a:r>
+                        <a:rPr sz="1090" b="1">
+                          <a:solidFill>
+                            <a:srgbClr val="2B2A26"/>
+                          </a:solidFill>
+                          <a:latin typeface="Aptos"/>
+                        </a:rPr>
+                        <a:t>Administrador/a de proyecto</a:t>
+                      </a:r>
+                    </a:p>
+                  </a:txBody>
+                  <a:tcPr marL="64008" marR="64008" marT="45720" marB="36576">
+                    <a:solidFill>
+                      <a:srgbClr val="FFFFFF"/>
+                    </a:solidFill>
+                  </a:tcPr>
+                </a:tc>
+                <a:tc>
+                  <a:txBody>
+                    <a:bodyPr/>
+                    <a:lstStyle/>
+                    <a:p>
+                      <a:pPr>
+                        <a:spcAft>
+                          <a:spcPts val="0"/>
+                        </a:spcAft>
+                      </a:pPr>
+                      <a:r>
+                        <a:rPr sz="1090" b="0">
+                          <a:solidFill>
+                            <a:srgbClr val="2B2A26"/>
+                          </a:solidFill>
+                          <a:latin typeface="Aptos"/>
+                        </a:rPr>
+                        <a:t>Planifica, coordina y supervisa el proyecto.</a:t>
+                      </a:r>
+                    </a:p>
+                  </a:txBody>
+                  <a:tcPr marL="64008" marR="64008" marT="45720" marB="36576">
+                    <a:solidFill>
+                      <a:srgbClr val="FFFFFF"/>
+                    </a:solidFill>
+                  </a:tcPr>
+                </a:tc>
+                <a:tc>
+                  <a:txBody>
+                    <a:bodyPr/>
+                    <a:lstStyle/>
+                    <a:p>
+                      <a:pPr>
+                        <a:spcAft>
+                          <a:spcPts val="0"/>
+                        </a:spcAft>
+                      </a:pPr>
+                      <a:r>
+                        <a:rPr sz="1090" b="0">
+                          <a:solidFill>
+                            <a:srgbClr val="2B2A26"/>
+                          </a:solidFill>
+                          <a:latin typeface="Aptos"/>
+                        </a:rPr>
+                        <a:t>Organiza iteraciones, recursos, plazos, riesgos e hitos.</a:t>
+                      </a:r>
+                    </a:p>
+                  </a:txBody>
+                  <a:tcPr marL="64008" marR="64008" marT="45720" marB="36576">
+                    <a:solidFill>
+                      <a:srgbClr val="FFFFFF"/>
+                    </a:solidFill>
+                  </a:tcPr>
+                </a:tc>
+              </a:tr>
+            </a:tbl>
+          </a:graphicData>
+        </a:graphic>
+      </p:graphicFrame>
+      <p:sp>
+        <p:nvSpPr>
+          <p:cNvPr id="9" name="Rounded Rectangle 8"/>
           <p:cNvSpPr/>
           <p:nvPr/>
         </p:nvSpPr>
         <p:spPr>
           <a:xfrm>
-            <a:off x="640080" y="1874519"/>
-            <a:ext cx="5230368" cy="1078992"/>
-          </a:xfrm>
-          <a:prstGeom prst="roundRect">
-            <a:avLst/>
-          </a:prstGeom>
-          <a:solidFill>
-            <a:srgbClr val="FFFFFF"/>
-          </a:solidFill>
-          <a:ln w="12700">
-            <a:solidFill>
-              <a:srgbClr val="DCD6CC"/>
-            </a:solidFill>
-          </a:ln>
-        </p:spPr>
-        <p:style>
-          <a:lnRef idx="1">
-            <a:schemeClr val="accent1"/>
-          </a:lnRef>
-          <a:fillRef idx="3">
-            <a:schemeClr val="accent1"/>
-          </a:fillRef>
-          <a:effectRef idx="2">
-            <a:schemeClr val="accent1"/>
-          </a:effectRef>
-          <a:fontRef idx="minor">
-            <a:schemeClr val="lt1"/>
-          </a:fontRef>
-        </p:style>
-        <p:txBody>
-          <a:bodyPr rtlCol="0" anchor="ctr"/>
-          <a:lstStyle/>
-          <a:p>
-            <a:pPr algn="ctr"/>
-          </a:p>
-        </p:txBody>
-      </p:sp>
-      <p:sp>
-        <p:nvSpPr>
-          <p:cNvPr id="9" name="Rectangle 8"/>
-          <p:cNvSpPr/>
-          <p:nvPr/>
-        </p:nvSpPr>
-        <p:spPr>
-          <a:xfrm>
-            <a:off x="640080" y="1874519"/>
-            <a:ext cx="73152" cy="1078992"/>
-          </a:xfrm>
-          <a:prstGeom prst="rect">
-            <a:avLst/>
-          </a:prstGeom>
-          <a:solidFill>
-            <a:srgbClr val="C04E5C"/>
-          </a:solidFill>
-          <a:ln>
-            <a:noFill/>
-          </a:ln>
-        </p:spPr>
-        <p:style>
-          <a:lnRef idx="1">
-            <a:schemeClr val="accent1"/>
-          </a:lnRef>
-          <a:fillRef idx="3">
-            <a:schemeClr val="accent1"/>
-          </a:fillRef>
-          <a:effectRef idx="2">
-            <a:schemeClr val="accent1"/>
-          </a:effectRef>
-          <a:fontRef idx="minor">
-            <a:schemeClr val="lt1"/>
-          </a:fontRef>
-        </p:style>
-        <p:txBody>
-          <a:bodyPr rtlCol="0" anchor="ctr"/>
-          <a:lstStyle/>
-          <a:p>
-            <a:pPr algn="ctr"/>
-          </a:p>
-        </p:txBody>
-      </p:sp>
-      <p:sp>
-        <p:nvSpPr>
-          <p:cNvPr id="10" name="TextBox 9"/>
-          <p:cNvSpPr txBox="1"/>
-          <p:nvPr/>
-        </p:nvSpPr>
-        <p:spPr>
-          <a:xfrm>
-            <a:off x="841247" y="2029967"/>
-            <a:ext cx="4882896" cy="320040"/>
-          </a:xfrm>
-          <a:prstGeom prst="rect">
-            <a:avLst/>
-          </a:prstGeom>
-          <a:noFill/>
-        </p:spPr>
-        <p:txBody>
-          <a:bodyPr wrap="square" lIns="54864" rIns="54864" tIns="54864" bIns="54864" anchor="t">
-            <a:spAutoFit/>
-          </a:bodyPr>
-          <a:lstStyle/>
-          <a:p>
-            <a:pPr algn="l"/>
-            <a:r>
-              <a:rPr sz="1400" b="1">
-                <a:solidFill>
-                  <a:srgbClr val="C04E5C"/>
-                </a:solidFill>
-                <a:latin typeface="Aptos"/>
-              </a:rPr>
-              <a:t>Administrador/a de proyecto</a:t>
-            </a:r>
-          </a:p>
-        </p:txBody>
-      </p:sp>
-      <p:sp>
-        <p:nvSpPr>
-          <p:cNvPr id="11" name="TextBox 10"/>
-          <p:cNvSpPr txBox="1"/>
-          <p:nvPr/>
-        </p:nvSpPr>
-        <p:spPr>
-          <a:xfrm>
-            <a:off x="841247" y="2441448"/>
-            <a:ext cx="4882896" cy="384047"/>
-          </a:xfrm>
-          <a:prstGeom prst="rect">
-            <a:avLst/>
-          </a:prstGeom>
-          <a:noFill/>
-        </p:spPr>
-        <p:txBody>
-          <a:bodyPr wrap="square" lIns="54864" rIns="54864" tIns="54864" bIns="54864" anchor="t">
-            <a:spAutoFit/>
-          </a:bodyPr>
-          <a:lstStyle/>
-          <a:p>
-            <a:pPr algn="l"/>
-            <a:r>
-              <a:rPr sz="1200" b="0">
-                <a:solidFill>
-                  <a:srgbClr val="2B2A26"/>
-                </a:solidFill>
-                <a:latin typeface="Aptos"/>
-              </a:rPr>
-              <a:t>Planifica, coordina y supervisa plazos, recursos e hitos.</a:t>
-            </a:r>
-          </a:p>
-        </p:txBody>
-      </p:sp>
-      <p:sp>
-        <p:nvSpPr>
-          <p:cNvPr id="12" name="Rounded Rectangle 11"/>
-          <p:cNvSpPr/>
-          <p:nvPr/>
-        </p:nvSpPr>
-        <p:spPr>
-          <a:xfrm>
-            <a:off x="6172200" y="1874519"/>
-            <a:ext cx="5230368" cy="1078992"/>
-          </a:xfrm>
-          <a:prstGeom prst="roundRect">
-            <a:avLst/>
-          </a:prstGeom>
-          <a:solidFill>
-            <a:srgbClr val="FFFFFF"/>
-          </a:solidFill>
-          <a:ln w="12700">
-            <a:solidFill>
-              <a:srgbClr val="DCD6CC"/>
-            </a:solidFill>
-          </a:ln>
-        </p:spPr>
-        <p:style>
-          <a:lnRef idx="1">
-            <a:schemeClr val="accent1"/>
-          </a:lnRef>
-          <a:fillRef idx="3">
-            <a:schemeClr val="accent1"/>
-          </a:fillRef>
-          <a:effectRef idx="2">
-            <a:schemeClr val="accent1"/>
-          </a:effectRef>
-          <a:fontRef idx="minor">
-            <a:schemeClr val="lt1"/>
-          </a:fontRef>
-        </p:style>
-        <p:txBody>
-          <a:bodyPr rtlCol="0" anchor="ctr"/>
-          <a:lstStyle/>
-          <a:p>
-            <a:pPr algn="ctr"/>
-          </a:p>
-        </p:txBody>
-      </p:sp>
-      <p:sp>
-        <p:nvSpPr>
-          <p:cNvPr id="13" name="Rectangle 12"/>
-          <p:cNvSpPr/>
-          <p:nvPr/>
-        </p:nvSpPr>
-        <p:spPr>
-          <a:xfrm>
-            <a:off x="6172200" y="1874519"/>
-            <a:ext cx="73152" cy="1078992"/>
-          </a:xfrm>
-          <a:prstGeom prst="rect">
-            <a:avLst/>
-          </a:prstGeom>
-          <a:solidFill>
-            <a:srgbClr val="664330"/>
-          </a:solidFill>
-          <a:ln>
-            <a:noFill/>
-          </a:ln>
-        </p:spPr>
-        <p:style>
-          <a:lnRef idx="1">
-            <a:schemeClr val="accent1"/>
-          </a:lnRef>
-          <a:fillRef idx="3">
-            <a:schemeClr val="accent1"/>
-          </a:fillRef>
-          <a:effectRef idx="2">
-            <a:schemeClr val="accent1"/>
-          </a:effectRef>
-          <a:fontRef idx="minor">
-            <a:schemeClr val="lt1"/>
-          </a:fontRef>
-        </p:style>
-        <p:txBody>
-          <a:bodyPr rtlCol="0" anchor="ctr"/>
-          <a:lstStyle/>
-          <a:p>
-            <a:pPr algn="ctr"/>
-          </a:p>
-        </p:txBody>
-      </p:sp>
-      <p:sp>
-        <p:nvSpPr>
-          <p:cNvPr id="14" name="TextBox 13"/>
-          <p:cNvSpPr txBox="1"/>
-          <p:nvPr/>
-        </p:nvSpPr>
-        <p:spPr>
-          <a:xfrm>
-            <a:off x="6373368" y="2029967"/>
-            <a:ext cx="4882896" cy="320040"/>
-          </a:xfrm>
-          <a:prstGeom prst="rect">
-            <a:avLst/>
-          </a:prstGeom>
-          <a:noFill/>
-        </p:spPr>
-        <p:txBody>
-          <a:bodyPr wrap="square" lIns="54864" rIns="54864" tIns="54864" bIns="54864" anchor="t">
-            <a:spAutoFit/>
-          </a:bodyPr>
-          <a:lstStyle/>
-          <a:p>
-            <a:pPr algn="l"/>
-            <a:r>
-              <a:rPr sz="1400" b="1">
-                <a:solidFill>
-                  <a:srgbClr val="664330"/>
-                </a:solidFill>
-                <a:latin typeface="Aptos"/>
-              </a:rPr>
-              <a:t>Analista</a:t>
-            </a:r>
-          </a:p>
-        </p:txBody>
-      </p:sp>
-      <p:sp>
-        <p:nvSpPr>
-          <p:cNvPr id="15" name="TextBox 14"/>
-          <p:cNvSpPr txBox="1"/>
-          <p:nvPr/>
-        </p:nvSpPr>
-        <p:spPr>
-          <a:xfrm>
-            <a:off x="6373368" y="2441448"/>
-            <a:ext cx="4882896" cy="384047"/>
-          </a:xfrm>
-          <a:prstGeom prst="rect">
-            <a:avLst/>
-          </a:prstGeom>
-          <a:noFill/>
-        </p:spPr>
-        <p:txBody>
-          <a:bodyPr wrap="square" lIns="54864" rIns="54864" tIns="54864" bIns="54864" anchor="t">
-            <a:spAutoFit/>
-          </a:bodyPr>
-          <a:lstStyle/>
-          <a:p>
-            <a:pPr algn="l"/>
-            <a:r>
-              <a:rPr sz="1200" b="0">
-                <a:solidFill>
-                  <a:srgbClr val="2B2A26"/>
-                </a:solidFill>
-                <a:latin typeface="Aptos"/>
-              </a:rPr>
-              <a:t>Captura y documenta los requisitos de clientes y administradores.</a:t>
-            </a:r>
-          </a:p>
-        </p:txBody>
-      </p:sp>
-      <p:sp>
-        <p:nvSpPr>
-          <p:cNvPr id="16" name="Rounded Rectangle 15"/>
-          <p:cNvSpPr/>
-          <p:nvPr/>
-        </p:nvSpPr>
-        <p:spPr>
-          <a:xfrm>
-            <a:off x="640080" y="3182111"/>
-            <a:ext cx="5230368" cy="1078992"/>
-          </a:xfrm>
-          <a:prstGeom prst="roundRect">
-            <a:avLst/>
-          </a:prstGeom>
-          <a:solidFill>
-            <a:srgbClr val="FFFFFF"/>
-          </a:solidFill>
-          <a:ln w="12700">
-            <a:solidFill>
-              <a:srgbClr val="DCD6CC"/>
-            </a:solidFill>
-          </a:ln>
-        </p:spPr>
-        <p:style>
-          <a:lnRef idx="1">
-            <a:schemeClr val="accent1"/>
-          </a:lnRef>
-          <a:fillRef idx="3">
-            <a:schemeClr val="accent1"/>
-          </a:fillRef>
-          <a:effectRef idx="2">
-            <a:schemeClr val="accent1"/>
-          </a:effectRef>
-          <a:fontRef idx="minor">
-            <a:schemeClr val="lt1"/>
-          </a:fontRef>
-        </p:style>
-        <p:txBody>
-          <a:bodyPr rtlCol="0" anchor="ctr"/>
-          <a:lstStyle/>
-          <a:p>
-            <a:pPr algn="ctr"/>
-          </a:p>
-        </p:txBody>
-      </p:sp>
-      <p:sp>
-        <p:nvSpPr>
-          <p:cNvPr id="17" name="Rectangle 16"/>
-          <p:cNvSpPr/>
-          <p:nvPr/>
-        </p:nvSpPr>
-        <p:spPr>
-          <a:xfrm>
-            <a:off x="640080" y="3182111"/>
-            <a:ext cx="73152" cy="1078992"/>
-          </a:xfrm>
-          <a:prstGeom prst="rect">
-            <a:avLst/>
-          </a:prstGeom>
-          <a:solidFill>
-            <a:srgbClr val="2E6958"/>
-          </a:solidFill>
-          <a:ln>
-            <a:noFill/>
-          </a:ln>
-        </p:spPr>
-        <p:style>
-          <a:lnRef idx="1">
-            <a:schemeClr val="accent1"/>
-          </a:lnRef>
-          <a:fillRef idx="3">
-            <a:schemeClr val="accent1"/>
-          </a:fillRef>
-          <a:effectRef idx="2">
-            <a:schemeClr val="accent1"/>
-          </a:effectRef>
-          <a:fontRef idx="minor">
-            <a:schemeClr val="lt1"/>
-          </a:fontRef>
-        </p:style>
-        <p:txBody>
-          <a:bodyPr rtlCol="0" anchor="ctr"/>
-          <a:lstStyle/>
-          <a:p>
-            <a:pPr algn="ctr"/>
-          </a:p>
-        </p:txBody>
-      </p:sp>
-      <p:sp>
-        <p:nvSpPr>
-          <p:cNvPr id="18" name="TextBox 17"/>
-          <p:cNvSpPr txBox="1"/>
-          <p:nvPr/>
-        </p:nvSpPr>
-        <p:spPr>
-          <a:xfrm>
-            <a:off x="841247" y="3337559"/>
-            <a:ext cx="4882896" cy="320040"/>
-          </a:xfrm>
-          <a:prstGeom prst="rect">
-            <a:avLst/>
-          </a:prstGeom>
-          <a:noFill/>
-        </p:spPr>
-        <p:txBody>
-          <a:bodyPr wrap="square" lIns="54864" rIns="54864" tIns="54864" bIns="54864" anchor="t">
-            <a:spAutoFit/>
-          </a:bodyPr>
-          <a:lstStyle/>
-          <a:p>
-            <a:pPr algn="l"/>
-            <a:r>
-              <a:rPr sz="1400" b="1">
-                <a:solidFill>
-                  <a:srgbClr val="2E6958"/>
-                </a:solidFill>
-                <a:latin typeface="Aptos"/>
-              </a:rPr>
-              <a:t>Diseñador/a</a:t>
-            </a:r>
-          </a:p>
-        </p:txBody>
-      </p:sp>
-      <p:sp>
-        <p:nvSpPr>
-          <p:cNvPr id="19" name="TextBox 18"/>
-          <p:cNvSpPr txBox="1"/>
-          <p:nvPr/>
-        </p:nvSpPr>
-        <p:spPr>
-          <a:xfrm>
-            <a:off x="841247" y="3749039"/>
-            <a:ext cx="4882896" cy="384047"/>
-          </a:xfrm>
-          <a:prstGeom prst="rect">
-            <a:avLst/>
-          </a:prstGeom>
-          <a:noFill/>
-        </p:spPr>
-        <p:txBody>
-          <a:bodyPr wrap="square" lIns="54864" rIns="54864" tIns="54864" bIns="54864" anchor="t">
-            <a:spAutoFit/>
-          </a:bodyPr>
-          <a:lstStyle/>
-          <a:p>
-            <a:pPr algn="l"/>
-            <a:r>
-              <a:rPr sz="1200" b="0">
-                <a:solidFill>
-                  <a:srgbClr val="2B2A26"/>
-                </a:solidFill>
-                <a:latin typeface="Aptos"/>
-              </a:rPr>
-              <a:t>Crea la arquitectura y los diagramas UML del sistema.</a:t>
-            </a:r>
-          </a:p>
-        </p:txBody>
-      </p:sp>
-      <p:sp>
-        <p:nvSpPr>
-          <p:cNvPr id="20" name="Rounded Rectangle 19"/>
-          <p:cNvSpPr/>
-          <p:nvPr/>
-        </p:nvSpPr>
-        <p:spPr>
-          <a:xfrm>
-            <a:off x="6172200" y="3182111"/>
-            <a:ext cx="5230368" cy="1078992"/>
-          </a:xfrm>
-          <a:prstGeom prst="roundRect">
-            <a:avLst/>
-          </a:prstGeom>
-          <a:solidFill>
-            <a:srgbClr val="FFFFFF"/>
-          </a:solidFill>
-          <a:ln w="12700">
-            <a:solidFill>
-              <a:srgbClr val="DCD6CC"/>
-            </a:solidFill>
-          </a:ln>
-        </p:spPr>
-        <p:style>
-          <a:lnRef idx="1">
-            <a:schemeClr val="accent1"/>
-          </a:lnRef>
-          <a:fillRef idx="3">
-            <a:schemeClr val="accent1"/>
-          </a:fillRef>
-          <a:effectRef idx="2">
-            <a:schemeClr val="accent1"/>
-          </a:effectRef>
-          <a:fontRef idx="minor">
-            <a:schemeClr val="lt1"/>
-          </a:fontRef>
-        </p:style>
-        <p:txBody>
-          <a:bodyPr rtlCol="0" anchor="ctr"/>
-          <a:lstStyle/>
-          <a:p>
-            <a:pPr algn="ctr"/>
-          </a:p>
-        </p:txBody>
-      </p:sp>
-      <p:sp>
-        <p:nvSpPr>
-          <p:cNvPr id="21" name="Rectangle 20"/>
-          <p:cNvSpPr/>
-          <p:nvPr/>
-        </p:nvSpPr>
-        <p:spPr>
-          <a:xfrm>
-            <a:off x="6172200" y="3182111"/>
-            <a:ext cx="73152" cy="1078992"/>
-          </a:xfrm>
-          <a:prstGeom prst="rect">
-            <a:avLst/>
-          </a:prstGeom>
-          <a:solidFill>
-            <a:srgbClr val="DAA64E"/>
-          </a:solidFill>
-          <a:ln>
-            <a:noFill/>
-          </a:ln>
-        </p:spPr>
-        <p:style>
-          <a:lnRef idx="1">
-            <a:schemeClr val="accent1"/>
-          </a:lnRef>
-          <a:fillRef idx="3">
-            <a:schemeClr val="accent1"/>
-          </a:fillRef>
-          <a:effectRef idx="2">
-            <a:schemeClr val="accent1"/>
-          </a:effectRef>
-          <a:fontRef idx="minor">
-            <a:schemeClr val="lt1"/>
-          </a:fontRef>
-        </p:style>
-        <p:txBody>
-          <a:bodyPr rtlCol="0" anchor="ctr"/>
-          <a:lstStyle/>
-          <a:p>
-            <a:pPr algn="ctr"/>
-          </a:p>
-        </p:txBody>
-      </p:sp>
-      <p:sp>
-        <p:nvSpPr>
-          <p:cNvPr id="22" name="TextBox 21"/>
-          <p:cNvSpPr txBox="1"/>
-          <p:nvPr/>
-        </p:nvSpPr>
-        <p:spPr>
-          <a:xfrm>
-            <a:off x="6373368" y="3337559"/>
-            <a:ext cx="4882896" cy="320040"/>
-          </a:xfrm>
-          <a:prstGeom prst="rect">
-            <a:avLst/>
-          </a:prstGeom>
-          <a:noFill/>
-        </p:spPr>
-        <p:txBody>
-          <a:bodyPr wrap="square" lIns="54864" rIns="54864" tIns="54864" bIns="54864" anchor="t">
-            <a:spAutoFit/>
-          </a:bodyPr>
-          <a:lstStyle/>
-          <a:p>
-            <a:pPr algn="l"/>
-            <a:r>
-              <a:rPr sz="1400" b="1">
-                <a:solidFill>
-                  <a:srgbClr val="DAA64E"/>
-                </a:solidFill>
-                <a:latin typeface="Aptos"/>
-              </a:rPr>
-              <a:t>Programador/a</a:t>
-            </a:r>
-          </a:p>
-        </p:txBody>
-      </p:sp>
-      <p:sp>
-        <p:nvSpPr>
-          <p:cNvPr id="23" name="TextBox 22"/>
-          <p:cNvSpPr txBox="1"/>
-          <p:nvPr/>
-        </p:nvSpPr>
-        <p:spPr>
-          <a:xfrm>
-            <a:off x="6373368" y="3749039"/>
-            <a:ext cx="4882896" cy="384047"/>
-          </a:xfrm>
-          <a:prstGeom prst="rect">
-            <a:avLst/>
-          </a:prstGeom>
-          <a:noFill/>
-        </p:spPr>
-        <p:txBody>
-          <a:bodyPr wrap="square" lIns="54864" rIns="54864" tIns="54864" bIns="54864" anchor="t">
-            <a:spAutoFit/>
-          </a:bodyPr>
-          <a:lstStyle/>
-          <a:p>
-            <a:pPr algn="l"/>
-            <a:r>
-              <a:rPr sz="1200" b="0">
-                <a:solidFill>
-                  <a:srgbClr val="2B2A26"/>
-                </a:solidFill>
-                <a:latin typeface="Aptos"/>
-              </a:rPr>
-              <a:t>Implementa el código de acceso, compras, stock y boletas.</a:t>
-            </a:r>
-          </a:p>
-        </p:txBody>
-      </p:sp>
-      <p:sp>
-        <p:nvSpPr>
-          <p:cNvPr id="24" name="Rounded Rectangle 23"/>
-          <p:cNvSpPr/>
-          <p:nvPr/>
-        </p:nvSpPr>
-        <p:spPr>
-          <a:xfrm>
-            <a:off x="3410712" y="4489704"/>
-            <a:ext cx="5230368" cy="1078992"/>
-          </a:xfrm>
-          <a:prstGeom prst="roundRect">
-            <a:avLst/>
-          </a:prstGeom>
-          <a:solidFill>
-            <a:srgbClr val="FFFFFF"/>
-          </a:solidFill>
-          <a:ln w="12700">
-            <a:solidFill>
-              <a:srgbClr val="DCD6CC"/>
-            </a:solidFill>
-          </a:ln>
-        </p:spPr>
-        <p:style>
-          <a:lnRef idx="1">
-            <a:schemeClr val="accent1"/>
-          </a:lnRef>
-          <a:fillRef idx="3">
-            <a:schemeClr val="accent1"/>
-          </a:fillRef>
-          <a:effectRef idx="2">
-            <a:schemeClr val="accent1"/>
-          </a:effectRef>
-          <a:fontRef idx="minor">
-            <a:schemeClr val="lt1"/>
-          </a:fontRef>
-        </p:style>
-        <p:txBody>
-          <a:bodyPr rtlCol="0" anchor="ctr"/>
-          <a:lstStyle/>
-          <a:p>
-            <a:pPr algn="ctr"/>
-          </a:p>
-        </p:txBody>
-      </p:sp>
-      <p:sp>
-        <p:nvSpPr>
-          <p:cNvPr id="25" name="Rectangle 24"/>
-          <p:cNvSpPr/>
-          <p:nvPr/>
-        </p:nvSpPr>
-        <p:spPr>
-          <a:xfrm>
-            <a:off x="3410712" y="4489704"/>
-            <a:ext cx="73152" cy="1078992"/>
-          </a:xfrm>
-          <a:prstGeom prst="rect">
-            <a:avLst/>
-          </a:prstGeom>
-          <a:solidFill>
-            <a:srgbClr val="C04E5C"/>
-          </a:solidFill>
-          <a:ln>
-            <a:noFill/>
-          </a:ln>
-        </p:spPr>
-        <p:style>
-          <a:lnRef idx="1">
-            <a:schemeClr val="accent1"/>
-          </a:lnRef>
-          <a:fillRef idx="3">
-            <a:schemeClr val="accent1"/>
-          </a:fillRef>
-          <a:effectRef idx="2">
-            <a:schemeClr val="accent1"/>
-          </a:effectRef>
-          <a:fontRef idx="minor">
-            <a:schemeClr val="lt1"/>
-          </a:fontRef>
-        </p:style>
-        <p:txBody>
-          <a:bodyPr rtlCol="0" anchor="ctr"/>
-          <a:lstStyle/>
-          <a:p>
-            <a:pPr algn="ctr"/>
-          </a:p>
-        </p:txBody>
-      </p:sp>
-      <p:sp>
-        <p:nvSpPr>
-          <p:cNvPr id="26" name="TextBox 25"/>
-          <p:cNvSpPr txBox="1"/>
-          <p:nvPr/>
-        </p:nvSpPr>
-        <p:spPr>
-          <a:xfrm>
-            <a:off x="3611880" y="4645152"/>
-            <a:ext cx="4882896" cy="320040"/>
-          </a:xfrm>
-          <a:prstGeom prst="rect">
-            <a:avLst/>
-          </a:prstGeom>
-          <a:noFill/>
-        </p:spPr>
-        <p:txBody>
-          <a:bodyPr wrap="square" lIns="54864" rIns="54864" tIns="54864" bIns="54864" anchor="t">
-            <a:spAutoFit/>
-          </a:bodyPr>
-          <a:lstStyle/>
-          <a:p>
-            <a:pPr algn="l"/>
-            <a:r>
-              <a:rPr sz="1400" b="1">
-                <a:solidFill>
-                  <a:srgbClr val="C04E5C"/>
-                </a:solidFill>
-                <a:latin typeface="Aptos"/>
-              </a:rPr>
-              <a:t>Tester</a:t>
-            </a:r>
-          </a:p>
-        </p:txBody>
-      </p:sp>
-      <p:sp>
-        <p:nvSpPr>
-          <p:cNvPr id="27" name="TextBox 26"/>
-          <p:cNvSpPr txBox="1"/>
-          <p:nvPr/>
-        </p:nvSpPr>
-        <p:spPr>
-          <a:xfrm>
-            <a:off x="3611880" y="5056632"/>
-            <a:ext cx="4882896" cy="384047"/>
-          </a:xfrm>
-          <a:prstGeom prst="rect">
-            <a:avLst/>
-          </a:prstGeom>
-          <a:noFill/>
-        </p:spPr>
-        <p:txBody>
-          <a:bodyPr wrap="square" lIns="54864" rIns="54864" tIns="54864" bIns="54864" anchor="t">
-            <a:spAutoFit/>
-          </a:bodyPr>
-          <a:lstStyle/>
-          <a:p>
-            <a:pPr algn="l"/>
-            <a:r>
-              <a:rPr sz="1200" b="0">
-                <a:solidFill>
-                  <a:srgbClr val="2B2A26"/>
-                </a:solidFill>
-                <a:latin typeface="Aptos"/>
-              </a:rPr>
-              <a:t>Verifica que el software cumpla los requisitos y criterios.</a:t>
-            </a:r>
-          </a:p>
-        </p:txBody>
-      </p:sp>
-      <p:sp>
-        <p:nvSpPr>
-          <p:cNvPr id="28" name="Rounded Rectangle 27"/>
-          <p:cNvSpPr/>
-          <p:nvPr/>
-        </p:nvSpPr>
-        <p:spPr>
-          <a:xfrm>
-            <a:off x="640080" y="5870448"/>
-            <a:ext cx="10762488" cy="393192"/>
+            <a:off x="566928" y="6007608"/>
+            <a:ext cx="11045952" cy="310896"/>
           </a:xfrm>
           <a:prstGeom prst="roundRect">
             <a:avLst/>
@@ -13845,14 +13579,14 @@
       </p:sp>
       <p:sp>
         <p:nvSpPr>
-          <p:cNvPr id="29" name="TextBox 28"/>
-          <p:cNvSpPr txBox="1"/>
-          <p:nvPr/>
-        </p:nvSpPr>
-        <p:spPr>
-          <a:xfrm>
-            <a:off x="841248" y="5943600"/>
-            <a:ext cx="10332720" cy="219456"/>
+          <p:cNvPr id="10" name="TextBox 9"/>
+          <p:cNvSpPr txBox="1"/>
+          <p:nvPr/>
+        </p:nvSpPr>
+        <p:spPr>
+          <a:xfrm>
+            <a:off x="786384" y="6062472"/>
+            <a:ext cx="10607040" cy="182880"/>
           </a:xfrm>
           <a:prstGeom prst="rect">
             <a:avLst/>
@@ -13867,7 +13601,7 @@
           <a:p>
             <a:pPr algn="ctr"/>
             <a:r>
-              <a:rPr sz="1000" b="1">
+              <a:rPr sz="900" b="1">
                 <a:solidFill>
                   <a:srgbClr val="C04E5C"/>
                 </a:solidFill>
@@ -13969,7 +13703,7 @@
                 </a:solidFill>
                 <a:latin typeface="Aptos"/>
               </a:rPr>
-              <a:t>Fases del Proceso Unificado</a:t>
+              <a:t>Tabla de fases del Proceso Unificado</a:t>
             </a:r>
           </a:p>
         </p:txBody>
@@ -14004,7 +13738,7 @@
                 </a:solidFill>
                 <a:latin typeface="Aptos"/>
               </a:rPr>
-              <a:t>Cada iteración recorre las etapas para los casos de uso seleccionados y produce un incremento.</a:t>
+              <a:t>Cada iteración aplica las etapas a los casos de uso seleccionados y produce un incremento.</a:t>
             </a:r>
           </a:p>
         </p:txBody>
@@ -14122,1072 +13856,609 @@
           </a:p>
         </p:txBody>
       </p:sp>
-      <p:sp>
-        <p:nvSpPr>
-          <p:cNvPr id="8" name="Rounded Rectangle 7"/>
-          <p:cNvSpPr/>
-          <p:nvPr/>
-        </p:nvSpPr>
-        <p:spPr>
-          <a:xfrm>
-            <a:off x="566928" y="1938528"/>
-            <a:ext cx="2615184" cy="3474720"/>
-          </a:xfrm>
-          <a:prstGeom prst="roundRect">
-            <a:avLst/>
-          </a:prstGeom>
-          <a:solidFill>
-            <a:srgbClr val="F5E4E5"/>
-          </a:solidFill>
-          <a:ln w="12700">
-            <a:solidFill>
-              <a:srgbClr val="F5E4E5"/>
-            </a:solidFill>
-          </a:ln>
-        </p:spPr>
-        <p:style>
-          <a:lnRef idx="1">
-            <a:schemeClr val="accent1"/>
-          </a:lnRef>
-          <a:fillRef idx="3">
-            <a:schemeClr val="accent1"/>
-          </a:fillRef>
-          <a:effectRef idx="2">
-            <a:schemeClr val="accent1"/>
-          </a:effectRef>
-          <a:fontRef idx="minor">
-            <a:schemeClr val="lt1"/>
-          </a:fontRef>
-        </p:style>
-        <p:txBody>
-          <a:bodyPr rtlCol="0" anchor="ctr"/>
+      <p:graphicFrame>
+        <p:nvGraphicFramePr>
+          <p:cNvPr id="8" name="Table 7"/>
+          <p:cNvGraphicFramePr>
+            <a:graphicFrameLocks noGrp="1"/>
+          </p:cNvGraphicFramePr>
+          <p:nvPr/>
+        </p:nvGraphicFramePr>
+        <p:xfrm>
+          <a:off x="393192" y="1810512"/>
+          <a:ext cx="11402567" cy="4096512"/>
+        </p:xfrm>
+        <a:graphic>
+          <a:graphicData uri="http://schemas.openxmlformats.org/drawingml/2006/table">
+            <a:tbl>
+              <a:tblPr firstRow="1" bandRow="1">
+                <a:tableStyleId>{5C22544A-7EE6-4342-B048-85BDC9FD1C3A}</a:tableStyleId>
+              </a:tblPr>
+              <a:tblGrid>
+                <a:gridCol w="1298448"/>
+                <a:gridCol w="3749039"/>
+                <a:gridCol w="2596896"/>
+                <a:gridCol w="3758184"/>
+              </a:tblGrid>
+              <a:tr h="819302">
+                <a:tc>
+                  <a:txBody>
+                    <a:bodyPr/>
+                    <a:lstStyle/>
+                    <a:p>
+                      <a:pPr>
+                        <a:spcAft>
+                          <a:spcPts val="0"/>
+                        </a:spcAft>
+                      </a:pPr>
+                      <a:r>
+                        <a:rPr sz="930" b="1">
+                          <a:solidFill>
+                            <a:srgbClr val="FFFFFF"/>
+                          </a:solidFill>
+                          <a:latin typeface="Aptos"/>
+                        </a:rPr>
+                        <a:t>Fase</a:t>
+                      </a:r>
+                    </a:p>
+                  </a:txBody>
+                  <a:tcPr marL="64008" marR="64008" marT="45720" marB="36576">
+                    <a:solidFill>
+                      <a:srgbClr val="2E6958"/>
+                    </a:solidFill>
+                  </a:tcPr>
+                </a:tc>
+                <a:tc>
+                  <a:txBody>
+                    <a:bodyPr/>
+                    <a:lstStyle/>
+                    <a:p>
+                      <a:pPr>
+                        <a:spcAft>
+                          <a:spcPts val="0"/>
+                        </a:spcAft>
+                      </a:pPr>
+                      <a:r>
+                        <a:rPr sz="930" b="1">
+                          <a:solidFill>
+                            <a:srgbClr val="FFFFFF"/>
+                          </a:solidFill>
+                          <a:latin typeface="Aptos"/>
+                        </a:rPr>
+                        <a:t>Actividades principales</a:t>
+                      </a:r>
+                    </a:p>
+                  </a:txBody>
+                  <a:tcPr marL="64008" marR="64008" marT="45720" marB="36576">
+                    <a:solidFill>
+                      <a:srgbClr val="2E6958"/>
+                    </a:solidFill>
+                  </a:tcPr>
+                </a:tc>
+                <a:tc>
+                  <a:txBody>
+                    <a:bodyPr/>
+                    <a:lstStyle/>
+                    <a:p>
+                      <a:pPr>
+                        <a:spcAft>
+                          <a:spcPts val="0"/>
+                        </a:spcAft>
+                      </a:pPr>
+                      <a:r>
+                        <a:rPr sz="930" b="1">
+                          <a:solidFill>
+                            <a:srgbClr val="FFFFFF"/>
+                          </a:solidFill>
+                          <a:latin typeface="Aptos"/>
+                        </a:rPr>
+                        <a:t>Artefactos comunes</a:t>
+                      </a:r>
+                    </a:p>
+                  </a:txBody>
+                  <a:tcPr marL="64008" marR="64008" marT="45720" marB="36576">
+                    <a:solidFill>
+                      <a:srgbClr val="2E6958"/>
+                    </a:solidFill>
+                  </a:tcPr>
+                </a:tc>
+                <a:tc>
+                  <a:txBody>
+                    <a:bodyPr/>
+                    <a:lstStyle/>
+                    <a:p>
+                      <a:pPr>
+                        <a:spcAft>
+                          <a:spcPts val="0"/>
+                        </a:spcAft>
+                      </a:pPr>
+                      <a:r>
+                        <a:rPr sz="930" b="1">
+                          <a:solidFill>
+                            <a:srgbClr val="FFFFFF"/>
+                          </a:solidFill>
+                          <a:latin typeface="Aptos"/>
+                        </a:rPr>
+                        <a:t>Aplicación en Dolce‑Vita</a:t>
+                      </a:r>
+                    </a:p>
+                  </a:txBody>
+                  <a:tcPr marL="64008" marR="64008" marT="45720" marB="36576">
+                    <a:solidFill>
+                      <a:srgbClr val="2E6958"/>
+                    </a:solidFill>
+                  </a:tcPr>
+                </a:tc>
+              </a:tr>
+              <a:tr h="819302">
+                <a:tc>
+                  <a:txBody>
+                    <a:bodyPr/>
+                    <a:lstStyle/>
+                    <a:p>
+                      <a:pPr>
+                        <a:spcAft>
+                          <a:spcPts val="0"/>
+                        </a:spcAft>
+                      </a:pPr>
+                      <a:r>
+                        <a:rPr sz="980" b="1">
+                          <a:solidFill>
+                            <a:srgbClr val="2B2A26"/>
+                          </a:solidFill>
+                          <a:latin typeface="Aptos"/>
+                        </a:rPr>
+                        <a:t>Inicio</a:t>
+                      </a:r>
+                    </a:p>
+                  </a:txBody>
+                  <a:tcPr marL="64008" marR="64008" marT="45720" marB="36576">
+                    <a:solidFill>
+                      <a:srgbClr val="FFFFFF"/>
+                    </a:solidFill>
+                  </a:tcPr>
+                </a:tc>
+                <a:tc>
+                  <a:txBody>
+                    <a:bodyPr/>
+                    <a:lstStyle/>
+                    <a:p>
+                      <a:pPr>
+                        <a:spcAft>
+                          <a:spcPts val="0"/>
+                        </a:spcAft>
+                      </a:pPr>
+                      <a:r>
+                        <a:rPr sz="980" b="0">
+                          <a:solidFill>
+                            <a:srgbClr val="2B2A26"/>
+                          </a:solidFill>
+                          <a:latin typeface="Aptos"/>
+                        </a:rPr>
+                        <a:t>Requisitos, alcance, planificación inicial y estimación de costos.</a:t>
+                      </a:r>
+                    </a:p>
+                  </a:txBody>
+                  <a:tcPr marL="64008" marR="64008" marT="45720" marB="36576">
+                    <a:solidFill>
+                      <a:srgbClr val="FFFFFF"/>
+                    </a:solidFill>
+                  </a:tcPr>
+                </a:tc>
+                <a:tc>
+                  <a:txBody>
+                    <a:bodyPr/>
+                    <a:lstStyle/>
+                    <a:p>
+                      <a:pPr>
+                        <a:spcAft>
+                          <a:spcPts val="0"/>
+                        </a:spcAft>
+                      </a:pPr>
+                      <a:r>
+                        <a:rPr sz="980" b="0">
+                          <a:solidFill>
+                            <a:srgbClr val="2B2A26"/>
+                          </a:solidFill>
+                          <a:latin typeface="Aptos"/>
+                        </a:rPr>
+                        <a:t>Casos de uso y documento de visión.</a:t>
+                      </a:r>
+                    </a:p>
+                  </a:txBody>
+                  <a:tcPr marL="64008" marR="64008" marT="45720" marB="36576">
+                    <a:solidFill>
+                      <a:srgbClr val="FFFFFF"/>
+                    </a:solidFill>
+                  </a:tcPr>
+                </a:tc>
+                <a:tc>
+                  <a:txBody>
+                    <a:bodyPr/>
+                    <a:lstStyle/>
+                    <a:p>
+                      <a:pPr>
+                        <a:spcAft>
+                          <a:spcPts val="0"/>
+                        </a:spcAft>
+                      </a:pPr>
+                      <a:r>
+                        <a:rPr sz="980" b="0">
+                          <a:solidFill>
+                            <a:srgbClr val="2B2A26"/>
+                          </a:solidFill>
+                          <a:latin typeface="Aptos"/>
+                        </a:rPr>
+                        <a:t>Priorizar acceso, compra, inventario, alertas y boleta.</a:t>
+                      </a:r>
+                    </a:p>
+                  </a:txBody>
+                  <a:tcPr marL="64008" marR="64008" marT="45720" marB="36576">
+                    <a:solidFill>
+                      <a:srgbClr val="FFFFFF"/>
+                    </a:solidFill>
+                  </a:tcPr>
+                </a:tc>
+              </a:tr>
+              <a:tr h="819302">
+                <a:tc>
+                  <a:txBody>
+                    <a:bodyPr/>
+                    <a:lstStyle/>
+                    <a:p>
+                      <a:pPr>
+                        <a:spcAft>
+                          <a:spcPts val="0"/>
+                        </a:spcAft>
+                      </a:pPr>
+                      <a:r>
+                        <a:rPr sz="980" b="1">
+                          <a:solidFill>
+                            <a:srgbClr val="2B2A26"/>
+                          </a:solidFill>
+                          <a:latin typeface="Aptos"/>
+                        </a:rPr>
+                        <a:t>Elaboración</a:t>
+                      </a:r>
+                    </a:p>
+                  </a:txBody>
+                  <a:tcPr marL="64008" marR="64008" marT="45720" marB="36576">
+                    <a:solidFill>
+                      <a:srgbClr val="F4F1EB"/>
+                    </a:solidFill>
+                  </a:tcPr>
+                </a:tc>
+                <a:tc>
+                  <a:txBody>
+                    <a:bodyPr/>
+                    <a:lstStyle/>
+                    <a:p>
+                      <a:pPr>
+                        <a:spcAft>
+                          <a:spcPts val="0"/>
+                        </a:spcAft>
+                      </a:pPr>
+                      <a:r>
+                        <a:rPr sz="980" b="0">
+                          <a:solidFill>
+                            <a:srgbClr val="2B2A26"/>
+                          </a:solidFill>
+                          <a:latin typeface="Aptos"/>
+                        </a:rPr>
+                        <a:t>Análisis y diseño, validación arquitectónica, iteraciones y riesgos.</a:t>
+                      </a:r>
+                    </a:p>
+                  </a:txBody>
+                  <a:tcPr marL="64008" marR="64008" marT="45720" marB="36576">
+                    <a:solidFill>
+                      <a:srgbClr val="F4F1EB"/>
+                    </a:solidFill>
+                  </a:tcPr>
+                </a:tc>
+                <a:tc>
+                  <a:txBody>
+                    <a:bodyPr/>
+                    <a:lstStyle/>
+                    <a:p>
+                      <a:pPr>
+                        <a:spcAft>
+                          <a:spcPts val="0"/>
+                        </a:spcAft>
+                      </a:pPr>
+                      <a:r>
+                        <a:rPr sz="980" b="0">
+                          <a:solidFill>
+                            <a:srgbClr val="2B2A26"/>
+                          </a:solidFill>
+                          <a:latin typeface="Aptos"/>
+                        </a:rPr>
+                        <a:t>Diagramas UML y prototipos.</a:t>
+                      </a:r>
+                    </a:p>
+                  </a:txBody>
+                  <a:tcPr marL="64008" marR="64008" marT="45720" marB="36576">
+                    <a:solidFill>
+                      <a:srgbClr val="F4F1EB"/>
+                    </a:solidFill>
+                  </a:tcPr>
+                </a:tc>
+                <a:tc>
+                  <a:txBody>
+                    <a:bodyPr/>
+                    <a:lstStyle/>
+                    <a:p>
+                      <a:pPr>
+                        <a:spcAft>
+                          <a:spcPts val="0"/>
+                        </a:spcAft>
+                      </a:pPr>
+                      <a:r>
+                        <a:rPr sz="980" b="0">
+                          <a:solidFill>
+                            <a:srgbClr val="2B2A26"/>
+                          </a:solidFill>
+                          <a:latin typeface="Aptos"/>
+                        </a:rPr>
+                        <a:t>Validar arquitectura de ventas, stock y usuarios.</a:t>
+                      </a:r>
+                    </a:p>
+                  </a:txBody>
+                  <a:tcPr marL="64008" marR="64008" marT="45720" marB="36576">
+                    <a:solidFill>
+                      <a:srgbClr val="F4F1EB"/>
+                    </a:solidFill>
+                  </a:tcPr>
+                </a:tc>
+              </a:tr>
+              <a:tr h="819302">
+                <a:tc>
+                  <a:txBody>
+                    <a:bodyPr/>
+                    <a:lstStyle/>
+                    <a:p>
+                      <a:pPr>
+                        <a:spcAft>
+                          <a:spcPts val="0"/>
+                        </a:spcAft>
+                      </a:pPr>
+                      <a:r>
+                        <a:rPr sz="980" b="1">
+                          <a:solidFill>
+                            <a:srgbClr val="2B2A26"/>
+                          </a:solidFill>
+                          <a:latin typeface="Aptos"/>
+                        </a:rPr>
+                        <a:t>Construcción</a:t>
+                      </a:r>
+                    </a:p>
+                  </a:txBody>
+                  <a:tcPr marL="64008" marR="64008" marT="45720" marB="36576">
+                    <a:solidFill>
+                      <a:srgbClr val="FFFFFF"/>
+                    </a:solidFill>
+                  </a:tcPr>
+                </a:tc>
+                <a:tc>
+                  <a:txBody>
+                    <a:bodyPr/>
+                    <a:lstStyle/>
+                    <a:p>
+                      <a:pPr>
+                        <a:spcAft>
+                          <a:spcPts val="0"/>
+                        </a:spcAft>
+                      </a:pPr>
+                      <a:r>
+                        <a:rPr sz="980" b="0">
+                          <a:solidFill>
+                            <a:srgbClr val="2B2A26"/>
+                          </a:solidFill>
+                          <a:latin typeface="Aptos"/>
+                        </a:rPr>
+                        <a:t>Implementación, integración, pruebas unitarias e iterativas y revisiones.</a:t>
+                      </a:r>
+                    </a:p>
+                  </a:txBody>
+                  <a:tcPr marL="64008" marR="64008" marT="45720" marB="36576">
+                    <a:solidFill>
+                      <a:srgbClr val="FFFFFF"/>
+                    </a:solidFill>
+                  </a:tcPr>
+                </a:tc>
+                <a:tc>
+                  <a:txBody>
+                    <a:bodyPr/>
+                    <a:lstStyle/>
+                    <a:p>
+                      <a:pPr>
+                        <a:spcAft>
+                          <a:spcPts val="0"/>
+                        </a:spcAft>
+                      </a:pPr>
+                      <a:r>
+                        <a:rPr sz="980" b="0">
+                          <a:solidFill>
+                            <a:srgbClr val="2B2A26"/>
+                          </a:solidFill>
+                          <a:latin typeface="Aptos"/>
+                        </a:rPr>
+                        <a:t>Código fuente y manuales técnicos.</a:t>
+                      </a:r>
+                    </a:p>
+                  </a:txBody>
+                  <a:tcPr marL="64008" marR="64008" marT="45720" marB="36576">
+                    <a:solidFill>
+                      <a:srgbClr val="FFFFFF"/>
+                    </a:solidFill>
+                  </a:tcPr>
+                </a:tc>
+                <a:tc>
+                  <a:txBody>
+                    <a:bodyPr/>
+                    <a:lstStyle/>
+                    <a:p>
+                      <a:pPr>
+                        <a:spcAft>
+                          <a:spcPts val="0"/>
+                        </a:spcAft>
+                      </a:pPr>
+                      <a:r>
+                        <a:rPr sz="980" b="0">
+                          <a:solidFill>
+                            <a:srgbClr val="2B2A26"/>
+                          </a:solidFill>
+                          <a:latin typeface="Aptos"/>
+                        </a:rPr>
+                        <a:t>Construir e integrar módulos por incremento.</a:t>
+                      </a:r>
+                    </a:p>
+                  </a:txBody>
+                  <a:tcPr marL="64008" marR="64008" marT="45720" marB="36576">
+                    <a:solidFill>
+                      <a:srgbClr val="FFFFFF"/>
+                    </a:solidFill>
+                  </a:tcPr>
+                </a:tc>
+              </a:tr>
+              <a:tr h="819304">
+                <a:tc>
+                  <a:txBody>
+                    <a:bodyPr/>
+                    <a:lstStyle/>
+                    <a:p>
+                      <a:pPr>
+                        <a:spcAft>
+                          <a:spcPts val="0"/>
+                        </a:spcAft>
+                      </a:pPr>
+                      <a:r>
+                        <a:rPr sz="980" b="1">
+                          <a:solidFill>
+                            <a:srgbClr val="2B2A26"/>
+                          </a:solidFill>
+                          <a:latin typeface="Aptos"/>
+                        </a:rPr>
+                        <a:t>Transición</a:t>
+                      </a:r>
+                    </a:p>
+                  </a:txBody>
+                  <a:tcPr marL="64008" marR="64008" marT="45720" marB="36576">
+                    <a:solidFill>
+                      <a:srgbClr val="F4F1EB"/>
+                    </a:solidFill>
+                  </a:tcPr>
+                </a:tc>
+                <a:tc>
+                  <a:txBody>
+                    <a:bodyPr/>
+                    <a:lstStyle/>
+                    <a:p>
+                      <a:pPr>
+                        <a:spcAft>
+                          <a:spcPts val="0"/>
+                        </a:spcAft>
+                      </a:pPr>
+                      <a:r>
+                        <a:rPr sz="980" b="0">
+                          <a:solidFill>
+                            <a:srgbClr val="2B2A26"/>
+                          </a:solidFill>
+                          <a:latin typeface="Aptos"/>
+                        </a:rPr>
+                        <a:t>Pruebas finales, despliegue, capacitación y estabilización.</a:t>
+                      </a:r>
+                    </a:p>
+                  </a:txBody>
+                  <a:tcPr marL="64008" marR="64008" marT="45720" marB="36576">
+                    <a:solidFill>
+                      <a:srgbClr val="F4F1EB"/>
+                    </a:solidFill>
+                  </a:tcPr>
+                </a:tc>
+                <a:tc>
+                  <a:txBody>
+                    <a:bodyPr/>
+                    <a:lstStyle/>
+                    <a:p>
+                      <a:pPr>
+                        <a:spcAft>
+                          <a:spcPts val="0"/>
+                        </a:spcAft>
+                      </a:pPr>
+                      <a:r>
+                        <a:rPr sz="980" b="0">
+                          <a:solidFill>
+                            <a:srgbClr val="2B2A26"/>
+                          </a:solidFill>
+                          <a:latin typeface="Aptos"/>
+                        </a:rPr>
+                        <a:t>Plan de despliegue y manuales de usuario.</a:t>
+                      </a:r>
+                    </a:p>
+                  </a:txBody>
+                  <a:tcPr marL="64008" marR="64008" marT="45720" marB="36576">
+                    <a:solidFill>
+                      <a:srgbClr val="F4F1EB"/>
+                    </a:solidFill>
+                  </a:tcPr>
+                </a:tc>
+                <a:tc>
+                  <a:txBody>
+                    <a:bodyPr/>
+                    <a:lstStyle/>
+                    <a:p>
+                      <a:pPr>
+                        <a:spcAft>
+                          <a:spcPts val="0"/>
+                        </a:spcAft>
+                      </a:pPr>
+                      <a:r>
+                        <a:rPr sz="980" b="0">
+                          <a:solidFill>
+                            <a:srgbClr val="2B2A26"/>
+                          </a:solidFill>
+                          <a:latin typeface="Aptos"/>
+                        </a:rPr>
+                        <a:t>Piloto, correcciones, capacitación y puesta en marcha.</a:t>
+                      </a:r>
+                    </a:p>
+                  </a:txBody>
+                  <a:tcPr marL="64008" marR="64008" marT="45720" marB="36576">
+                    <a:solidFill>
+                      <a:srgbClr val="F4F1EB"/>
+                    </a:solidFill>
+                  </a:tcPr>
+                </a:tc>
+              </a:tr>
+            </a:tbl>
+          </a:graphicData>
+        </a:graphic>
+      </p:graphicFrame>
+      <p:sp>
+        <p:nvSpPr>
+          <p:cNvPr id="9" name="TextBox 8"/>
+          <p:cNvSpPr txBox="1"/>
+          <p:nvPr/>
+        </p:nvSpPr>
+        <p:spPr>
+          <a:xfrm>
+            <a:off x="749808" y="6016752"/>
+            <a:ext cx="10698480" cy="274320"/>
+          </a:xfrm>
+          <a:prstGeom prst="rect">
+            <a:avLst/>
+          </a:prstGeom>
+          <a:noFill/>
+        </p:spPr>
+        <p:txBody>
+          <a:bodyPr wrap="square" lIns="54864" rIns="54864" tIns="54864" bIns="54864" anchor="t">
+            <a:spAutoFit/>
+          </a:bodyPr>
           <a:lstStyle/>
           <a:p>
             <a:pPr algn="ctr"/>
-          </a:p>
-        </p:txBody>
-      </p:sp>
-      <p:sp>
-        <p:nvSpPr>
-          <p:cNvPr id="9" name="TextBox 8"/>
-          <p:cNvSpPr txBox="1"/>
-          <p:nvPr/>
-        </p:nvSpPr>
-        <p:spPr>
-          <a:xfrm>
-            <a:off x="749808" y="2148840"/>
-            <a:ext cx="457200" cy="292608"/>
-          </a:xfrm>
-          <a:prstGeom prst="rect">
-            <a:avLst/>
-          </a:prstGeom>
-          <a:noFill/>
-        </p:spPr>
-        <p:txBody>
-          <a:bodyPr wrap="square" lIns="54864" rIns="54864" tIns="54864" bIns="54864" anchor="t">
-            <a:spAutoFit/>
-          </a:bodyPr>
-          <a:lstStyle/>
-          <a:p>
-            <a:pPr algn="l"/>
-            <a:r>
-              <a:rPr sz="1200" b="1">
-                <a:solidFill>
-                  <a:srgbClr val="C04E5C"/>
-                </a:solidFill>
-                <a:latin typeface="Aptos"/>
-              </a:rPr>
-              <a:t>01</a:t>
-            </a:r>
-          </a:p>
-        </p:txBody>
-      </p:sp>
-      <p:sp>
-        <p:nvSpPr>
-          <p:cNvPr id="10" name="TextBox 9"/>
-          <p:cNvSpPr txBox="1"/>
-          <p:nvPr/>
-        </p:nvSpPr>
-        <p:spPr>
-          <a:xfrm>
-            <a:off x="749808" y="2560320"/>
-            <a:ext cx="2148840" cy="347472"/>
-          </a:xfrm>
-          <a:prstGeom prst="rect">
-            <a:avLst/>
-          </a:prstGeom>
-          <a:noFill/>
-        </p:spPr>
-        <p:txBody>
-          <a:bodyPr wrap="square" lIns="54864" rIns="54864" tIns="54864" bIns="54864" anchor="t">
-            <a:spAutoFit/>
-          </a:bodyPr>
-          <a:lstStyle/>
-          <a:p>
-            <a:pPr algn="l"/>
-            <a:r>
-              <a:rPr sz="1800" b="1">
-                <a:solidFill>
-                  <a:srgbClr val="2B2A26"/>
-                </a:solidFill>
-                <a:latin typeface="Aptos"/>
-              </a:rPr>
-              <a:t>Inicio</a:t>
-            </a:r>
-          </a:p>
-        </p:txBody>
-      </p:sp>
-      <p:sp>
-        <p:nvSpPr>
-          <p:cNvPr id="11" name="TextBox 10"/>
-          <p:cNvSpPr txBox="1"/>
-          <p:nvPr/>
-        </p:nvSpPr>
-        <p:spPr>
-          <a:xfrm>
-            <a:off x="749808" y="3127248"/>
-            <a:ext cx="2212848" cy="1234440"/>
-          </a:xfrm>
-          <a:prstGeom prst="rect">
-            <a:avLst/>
-          </a:prstGeom>
-          <a:noFill/>
-        </p:spPr>
-        <p:txBody>
-          <a:bodyPr wrap="square" lIns="54864" rIns="54864" tIns="54864" bIns="54864" anchor="t">
-            <a:spAutoFit/>
-          </a:bodyPr>
-          <a:lstStyle/>
-          <a:p>
-            <a:pPr algn="l"/>
-            <a:r>
-              <a:rPr sz="1300" b="0">
-                <a:solidFill>
-                  <a:srgbClr val="2B2A26"/>
-                </a:solidFill>
-                <a:latin typeface="Aptos"/>
-              </a:rPr>
-              <a:t>Levantar requisitos, definir alcance, realizar la planificación inicial y estimar costos.</a:t>
-            </a:r>
-          </a:p>
-        </p:txBody>
-      </p:sp>
-      <p:sp>
-        <p:nvSpPr>
-          <p:cNvPr id="12" name="Rectangle 11"/>
-          <p:cNvSpPr/>
-          <p:nvPr/>
-        </p:nvSpPr>
-        <p:spPr>
-          <a:xfrm>
-            <a:off x="749808" y="4599432"/>
-            <a:ext cx="2176272" cy="18288"/>
-          </a:xfrm>
-          <a:prstGeom prst="rect">
-            <a:avLst/>
-          </a:prstGeom>
-          <a:solidFill>
-            <a:srgbClr val="C04E5C"/>
-          </a:solidFill>
-          <a:ln>
-            <a:noFill/>
-          </a:ln>
-        </p:spPr>
-        <p:style>
-          <a:lnRef idx="1">
-            <a:schemeClr val="accent1"/>
-          </a:lnRef>
-          <a:fillRef idx="3">
-            <a:schemeClr val="accent1"/>
-          </a:fillRef>
-          <a:effectRef idx="2">
-            <a:schemeClr val="accent1"/>
-          </a:effectRef>
-          <a:fontRef idx="minor">
-            <a:schemeClr val="lt1"/>
-          </a:fontRef>
-        </p:style>
-        <p:txBody>
-          <a:bodyPr rtlCol="0" anchor="ctr"/>
-          <a:lstStyle/>
-          <a:p>
-            <a:pPr algn="ctr"/>
-          </a:p>
-        </p:txBody>
-      </p:sp>
-      <p:sp>
-        <p:nvSpPr>
-          <p:cNvPr id="13" name="TextBox 12"/>
-          <p:cNvSpPr txBox="1"/>
-          <p:nvPr/>
-        </p:nvSpPr>
-        <p:spPr>
-          <a:xfrm>
-            <a:off x="749808" y="4800600"/>
-            <a:ext cx="2212848" cy="320040"/>
-          </a:xfrm>
-          <a:prstGeom prst="rect">
-            <a:avLst/>
-          </a:prstGeom>
-          <a:noFill/>
-        </p:spPr>
-        <p:txBody>
-          <a:bodyPr wrap="square" lIns="54864" rIns="54864" tIns="54864" bIns="54864" anchor="t">
-            <a:spAutoFit/>
-          </a:bodyPr>
-          <a:lstStyle/>
-          <a:p>
-            <a:pPr algn="l"/>
-            <a:r>
-              <a:rPr sz="1100" b="1">
-                <a:solidFill>
-                  <a:srgbClr val="C04E5C"/>
-                </a:solidFill>
-                <a:latin typeface="Aptos"/>
-              </a:rPr>
-              <a:t>Artefactos: casos de uso y visión</a:t>
-            </a:r>
-          </a:p>
-        </p:txBody>
-      </p:sp>
-      <p:sp>
-        <p:nvSpPr>
-          <p:cNvPr id="14" name="Rounded Rectangle 13"/>
-          <p:cNvSpPr/>
-          <p:nvPr/>
-        </p:nvSpPr>
-        <p:spPr>
-          <a:xfrm>
-            <a:off x="3438144" y="1938528"/>
-            <a:ext cx="2615184" cy="3474720"/>
-          </a:xfrm>
-          <a:prstGeom prst="roundRect">
-            <a:avLst/>
-          </a:prstGeom>
-          <a:solidFill>
-            <a:srgbClr val="E2EEE9"/>
-          </a:solidFill>
-          <a:ln w="12700">
-            <a:solidFill>
-              <a:srgbClr val="E2EEE9"/>
-            </a:solidFill>
-          </a:ln>
-        </p:spPr>
-        <p:style>
-          <a:lnRef idx="1">
-            <a:schemeClr val="accent1"/>
-          </a:lnRef>
-          <a:fillRef idx="3">
-            <a:schemeClr val="accent1"/>
-          </a:fillRef>
-          <a:effectRef idx="2">
-            <a:schemeClr val="accent1"/>
-          </a:effectRef>
-          <a:fontRef idx="minor">
-            <a:schemeClr val="lt1"/>
-          </a:fontRef>
-        </p:style>
-        <p:txBody>
-          <a:bodyPr rtlCol="0" anchor="ctr"/>
-          <a:lstStyle/>
-          <a:p>
-            <a:pPr algn="ctr"/>
-          </a:p>
-        </p:txBody>
-      </p:sp>
-      <p:sp>
-        <p:nvSpPr>
-          <p:cNvPr id="15" name="TextBox 14"/>
-          <p:cNvSpPr txBox="1"/>
-          <p:nvPr/>
-        </p:nvSpPr>
-        <p:spPr>
-          <a:xfrm>
-            <a:off x="3621024" y="2148840"/>
-            <a:ext cx="457200" cy="292608"/>
-          </a:xfrm>
-          <a:prstGeom prst="rect">
-            <a:avLst/>
-          </a:prstGeom>
-          <a:noFill/>
-        </p:spPr>
-        <p:txBody>
-          <a:bodyPr wrap="square" lIns="54864" rIns="54864" tIns="54864" bIns="54864" anchor="t">
-            <a:spAutoFit/>
-          </a:bodyPr>
-          <a:lstStyle/>
-          <a:p>
-            <a:pPr algn="l"/>
-            <a:r>
-              <a:rPr sz="1200" b="1">
-                <a:solidFill>
-                  <a:srgbClr val="2E6958"/>
-                </a:solidFill>
-                <a:latin typeface="Aptos"/>
-              </a:rPr>
-              <a:t>02</a:t>
-            </a:r>
-          </a:p>
-        </p:txBody>
-      </p:sp>
-      <p:sp>
-        <p:nvSpPr>
-          <p:cNvPr id="16" name="TextBox 15"/>
-          <p:cNvSpPr txBox="1"/>
-          <p:nvPr/>
-        </p:nvSpPr>
-        <p:spPr>
-          <a:xfrm>
-            <a:off x="3621024" y="2560320"/>
-            <a:ext cx="2148840" cy="347472"/>
-          </a:xfrm>
-          <a:prstGeom prst="rect">
-            <a:avLst/>
-          </a:prstGeom>
-          <a:noFill/>
-        </p:spPr>
-        <p:txBody>
-          <a:bodyPr wrap="square" lIns="54864" rIns="54864" tIns="54864" bIns="54864" anchor="t">
-            <a:spAutoFit/>
-          </a:bodyPr>
-          <a:lstStyle/>
-          <a:p>
-            <a:pPr algn="l"/>
-            <a:r>
-              <a:rPr sz="1800" b="1">
-                <a:solidFill>
-                  <a:srgbClr val="2B2A26"/>
-                </a:solidFill>
-                <a:latin typeface="Aptos"/>
-              </a:rPr>
-              <a:t>Elaboración</a:t>
-            </a:r>
-          </a:p>
-        </p:txBody>
-      </p:sp>
-      <p:sp>
-        <p:nvSpPr>
-          <p:cNvPr id="17" name="TextBox 16"/>
-          <p:cNvSpPr txBox="1"/>
-          <p:nvPr/>
-        </p:nvSpPr>
-        <p:spPr>
-          <a:xfrm>
-            <a:off x="3621024" y="3127248"/>
-            <a:ext cx="2212848" cy="1234440"/>
-          </a:xfrm>
-          <a:prstGeom prst="rect">
-            <a:avLst/>
-          </a:prstGeom>
-          <a:noFill/>
-        </p:spPr>
-        <p:txBody>
-          <a:bodyPr wrap="square" lIns="54864" rIns="54864" tIns="54864" bIns="54864" anchor="t">
-            <a:spAutoFit/>
-          </a:bodyPr>
-          <a:lstStyle/>
-          <a:p>
-            <a:pPr algn="l"/>
-            <a:r>
-              <a:rPr sz="1300" b="0">
-                <a:solidFill>
-                  <a:srgbClr val="2B2A26"/>
-                </a:solidFill>
-                <a:latin typeface="Aptos"/>
-              </a:rPr>
-              <a:t>Analizar y diseñar, validar la arquitectura, planificar iteraciones y gestionar riesgos.</a:t>
-            </a:r>
-          </a:p>
-        </p:txBody>
-      </p:sp>
-      <p:sp>
-        <p:nvSpPr>
-          <p:cNvPr id="18" name="Rectangle 17"/>
-          <p:cNvSpPr/>
-          <p:nvPr/>
-        </p:nvSpPr>
-        <p:spPr>
-          <a:xfrm>
-            <a:off x="3621024" y="4599432"/>
-            <a:ext cx="2176272" cy="18288"/>
-          </a:xfrm>
-          <a:prstGeom prst="rect">
-            <a:avLst/>
-          </a:prstGeom>
-          <a:solidFill>
-            <a:srgbClr val="2E6958"/>
-          </a:solidFill>
-          <a:ln>
-            <a:noFill/>
-          </a:ln>
-        </p:spPr>
-        <p:style>
-          <a:lnRef idx="1">
-            <a:schemeClr val="accent1"/>
-          </a:lnRef>
-          <a:fillRef idx="3">
-            <a:schemeClr val="accent1"/>
-          </a:fillRef>
-          <a:effectRef idx="2">
-            <a:schemeClr val="accent1"/>
-          </a:effectRef>
-          <a:fontRef idx="minor">
-            <a:schemeClr val="lt1"/>
-          </a:fontRef>
-        </p:style>
-        <p:txBody>
-          <a:bodyPr rtlCol="0" anchor="ctr"/>
-          <a:lstStyle/>
-          <a:p>
-            <a:pPr algn="ctr"/>
-          </a:p>
-        </p:txBody>
-      </p:sp>
-      <p:sp>
-        <p:nvSpPr>
-          <p:cNvPr id="19" name="TextBox 18"/>
-          <p:cNvSpPr txBox="1"/>
-          <p:nvPr/>
-        </p:nvSpPr>
-        <p:spPr>
-          <a:xfrm>
-            <a:off x="3621024" y="4800600"/>
-            <a:ext cx="2212848" cy="320040"/>
-          </a:xfrm>
-          <a:prstGeom prst="rect">
-            <a:avLst/>
-          </a:prstGeom>
-          <a:noFill/>
-        </p:spPr>
-        <p:txBody>
-          <a:bodyPr wrap="square" lIns="54864" rIns="54864" tIns="54864" bIns="54864" anchor="t">
-            <a:spAutoFit/>
-          </a:bodyPr>
-          <a:lstStyle/>
-          <a:p>
-            <a:pPr algn="l"/>
-            <a:r>
-              <a:rPr sz="1100" b="1">
-                <a:solidFill>
-                  <a:srgbClr val="2E6958"/>
-                </a:solidFill>
-                <a:latin typeface="Aptos"/>
-              </a:rPr>
-              <a:t>Artefactos: UML y prototipos</a:t>
-            </a:r>
-          </a:p>
-        </p:txBody>
-      </p:sp>
-      <p:sp>
-        <p:nvSpPr>
-          <p:cNvPr id="20" name="Rounded Rectangle 19"/>
-          <p:cNvSpPr/>
-          <p:nvPr/>
-        </p:nvSpPr>
-        <p:spPr>
-          <a:xfrm>
-            <a:off x="6309360" y="1938528"/>
-            <a:ext cx="2615184" cy="3474720"/>
-          </a:xfrm>
-          <a:prstGeom prst="roundRect">
-            <a:avLst/>
-          </a:prstGeom>
-          <a:solidFill>
-            <a:srgbClr val="F7EDD5"/>
-          </a:solidFill>
-          <a:ln w="12700">
-            <a:solidFill>
-              <a:srgbClr val="F7EDD5"/>
-            </a:solidFill>
-          </a:ln>
-        </p:spPr>
-        <p:style>
-          <a:lnRef idx="1">
-            <a:schemeClr val="accent1"/>
-          </a:lnRef>
-          <a:fillRef idx="3">
-            <a:schemeClr val="accent1"/>
-          </a:fillRef>
-          <a:effectRef idx="2">
-            <a:schemeClr val="accent1"/>
-          </a:effectRef>
-          <a:fontRef idx="minor">
-            <a:schemeClr val="lt1"/>
-          </a:fontRef>
-        </p:style>
-        <p:txBody>
-          <a:bodyPr rtlCol="0" anchor="ctr"/>
-          <a:lstStyle/>
-          <a:p>
-            <a:pPr algn="ctr"/>
-          </a:p>
-        </p:txBody>
-      </p:sp>
-      <p:sp>
-        <p:nvSpPr>
-          <p:cNvPr id="21" name="TextBox 20"/>
-          <p:cNvSpPr txBox="1"/>
-          <p:nvPr/>
-        </p:nvSpPr>
-        <p:spPr>
-          <a:xfrm>
-            <a:off x="6492240" y="2148840"/>
-            <a:ext cx="457200" cy="292608"/>
-          </a:xfrm>
-          <a:prstGeom prst="rect">
-            <a:avLst/>
-          </a:prstGeom>
-          <a:noFill/>
-        </p:spPr>
-        <p:txBody>
-          <a:bodyPr wrap="square" lIns="54864" rIns="54864" tIns="54864" bIns="54864" anchor="t">
-            <a:spAutoFit/>
-          </a:bodyPr>
-          <a:lstStyle/>
-          <a:p>
-            <a:pPr algn="l"/>
-            <a:r>
-              <a:rPr sz="1200" b="1">
-                <a:solidFill>
-                  <a:srgbClr val="DAA64E"/>
-                </a:solidFill>
-                <a:latin typeface="Aptos"/>
-              </a:rPr>
-              <a:t>03</a:t>
-            </a:r>
-          </a:p>
-        </p:txBody>
-      </p:sp>
-      <p:sp>
-        <p:nvSpPr>
-          <p:cNvPr id="22" name="TextBox 21"/>
-          <p:cNvSpPr txBox="1"/>
-          <p:nvPr/>
-        </p:nvSpPr>
-        <p:spPr>
-          <a:xfrm>
-            <a:off x="6492240" y="2560320"/>
-            <a:ext cx="2148840" cy="347472"/>
-          </a:xfrm>
-          <a:prstGeom prst="rect">
-            <a:avLst/>
-          </a:prstGeom>
-          <a:noFill/>
-        </p:spPr>
-        <p:txBody>
-          <a:bodyPr wrap="square" lIns="54864" rIns="54864" tIns="54864" bIns="54864" anchor="t">
-            <a:spAutoFit/>
-          </a:bodyPr>
-          <a:lstStyle/>
-          <a:p>
-            <a:pPr algn="l"/>
-            <a:r>
-              <a:rPr sz="1800" b="1">
-                <a:solidFill>
-                  <a:srgbClr val="2B2A26"/>
-                </a:solidFill>
-                <a:latin typeface="Aptos"/>
-              </a:rPr>
-              <a:t>Construcción</a:t>
-            </a:r>
-          </a:p>
-        </p:txBody>
-      </p:sp>
-      <p:sp>
-        <p:nvSpPr>
-          <p:cNvPr id="23" name="TextBox 22"/>
-          <p:cNvSpPr txBox="1"/>
-          <p:nvPr/>
-        </p:nvSpPr>
-        <p:spPr>
-          <a:xfrm>
-            <a:off x="6492240" y="3127248"/>
-            <a:ext cx="2212848" cy="1234440"/>
-          </a:xfrm>
-          <a:prstGeom prst="rect">
-            <a:avLst/>
-          </a:prstGeom>
-          <a:noFill/>
-        </p:spPr>
-        <p:txBody>
-          <a:bodyPr wrap="square" lIns="54864" rIns="54864" tIns="54864" bIns="54864" anchor="t">
-            <a:spAutoFit/>
-          </a:bodyPr>
-          <a:lstStyle/>
-          <a:p>
-            <a:pPr algn="l"/>
-            <a:r>
-              <a:rPr sz="1300" b="0">
-                <a:solidFill>
-                  <a:srgbClr val="2B2A26"/>
-                </a:solidFill>
-                <a:latin typeface="Aptos"/>
-              </a:rPr>
-              <a:t>Implementar, integrar y ejecutar pruebas unitarias e iterativas con revisiones de avance.</a:t>
-            </a:r>
-          </a:p>
-        </p:txBody>
-      </p:sp>
-      <p:sp>
-        <p:nvSpPr>
-          <p:cNvPr id="24" name="Rectangle 23"/>
-          <p:cNvSpPr/>
-          <p:nvPr/>
-        </p:nvSpPr>
-        <p:spPr>
-          <a:xfrm>
-            <a:off x="6492240" y="4599432"/>
-            <a:ext cx="2176272" cy="18288"/>
-          </a:xfrm>
-          <a:prstGeom prst="rect">
-            <a:avLst/>
-          </a:prstGeom>
-          <a:solidFill>
-            <a:srgbClr val="DAA64E"/>
-          </a:solidFill>
-          <a:ln>
-            <a:noFill/>
-          </a:ln>
-        </p:spPr>
-        <p:style>
-          <a:lnRef idx="1">
-            <a:schemeClr val="accent1"/>
-          </a:lnRef>
-          <a:fillRef idx="3">
-            <a:schemeClr val="accent1"/>
-          </a:fillRef>
-          <a:effectRef idx="2">
-            <a:schemeClr val="accent1"/>
-          </a:effectRef>
-          <a:fontRef idx="minor">
-            <a:schemeClr val="lt1"/>
-          </a:fontRef>
-        </p:style>
-        <p:txBody>
-          <a:bodyPr rtlCol="0" anchor="ctr"/>
-          <a:lstStyle/>
-          <a:p>
-            <a:pPr algn="ctr"/>
-          </a:p>
-        </p:txBody>
-      </p:sp>
-      <p:sp>
-        <p:nvSpPr>
-          <p:cNvPr id="25" name="TextBox 24"/>
-          <p:cNvSpPr txBox="1"/>
-          <p:nvPr/>
-        </p:nvSpPr>
-        <p:spPr>
-          <a:xfrm>
-            <a:off x="6492240" y="4800600"/>
-            <a:ext cx="2212848" cy="320040"/>
-          </a:xfrm>
-          <a:prstGeom prst="rect">
-            <a:avLst/>
-          </a:prstGeom>
-          <a:noFill/>
-        </p:spPr>
-        <p:txBody>
-          <a:bodyPr wrap="square" lIns="54864" rIns="54864" tIns="54864" bIns="54864" anchor="t">
-            <a:spAutoFit/>
-          </a:bodyPr>
-          <a:lstStyle/>
-          <a:p>
-            <a:pPr algn="l"/>
-            <a:r>
-              <a:rPr sz="1100" b="1">
-                <a:solidFill>
-                  <a:srgbClr val="DAA64E"/>
-                </a:solidFill>
-                <a:latin typeface="Aptos"/>
-              </a:rPr>
-              <a:t>Artefactos: código y manual técnico</a:t>
-            </a:r>
-          </a:p>
-        </p:txBody>
-      </p:sp>
-      <p:sp>
-        <p:nvSpPr>
-          <p:cNvPr id="26" name="Rounded Rectangle 25"/>
-          <p:cNvSpPr/>
-          <p:nvPr/>
-        </p:nvSpPr>
-        <p:spPr>
-          <a:xfrm>
-            <a:off x="9180576" y="1938528"/>
-            <a:ext cx="2615184" cy="3474720"/>
-          </a:xfrm>
-          <a:prstGeom prst="roundRect">
-            <a:avLst/>
-          </a:prstGeom>
-          <a:solidFill>
-            <a:srgbClr val="EEE7E2"/>
-          </a:solidFill>
-          <a:ln w="12700">
-            <a:solidFill>
-              <a:srgbClr val="EEE7E2"/>
-            </a:solidFill>
-          </a:ln>
-        </p:spPr>
-        <p:style>
-          <a:lnRef idx="1">
-            <a:schemeClr val="accent1"/>
-          </a:lnRef>
-          <a:fillRef idx="3">
-            <a:schemeClr val="accent1"/>
-          </a:fillRef>
-          <a:effectRef idx="2">
-            <a:schemeClr val="accent1"/>
-          </a:effectRef>
-          <a:fontRef idx="minor">
-            <a:schemeClr val="lt1"/>
-          </a:fontRef>
-        </p:style>
-        <p:txBody>
-          <a:bodyPr rtlCol="0" anchor="ctr"/>
-          <a:lstStyle/>
-          <a:p>
-            <a:pPr algn="ctr"/>
-          </a:p>
-        </p:txBody>
-      </p:sp>
-      <p:sp>
-        <p:nvSpPr>
-          <p:cNvPr id="27" name="TextBox 26"/>
-          <p:cNvSpPr txBox="1"/>
-          <p:nvPr/>
-        </p:nvSpPr>
-        <p:spPr>
-          <a:xfrm>
-            <a:off x="9363455" y="2148840"/>
-            <a:ext cx="457200" cy="292608"/>
-          </a:xfrm>
-          <a:prstGeom prst="rect">
-            <a:avLst/>
-          </a:prstGeom>
-          <a:noFill/>
-        </p:spPr>
-        <p:txBody>
-          <a:bodyPr wrap="square" lIns="54864" rIns="54864" tIns="54864" bIns="54864" anchor="t">
-            <a:spAutoFit/>
-          </a:bodyPr>
-          <a:lstStyle/>
-          <a:p>
-            <a:pPr algn="l"/>
-            <a:r>
-              <a:rPr sz="1200" b="1">
-                <a:solidFill>
-                  <a:srgbClr val="664330"/>
-                </a:solidFill>
-                <a:latin typeface="Aptos"/>
-              </a:rPr>
-              <a:t>04</a:t>
-            </a:r>
-          </a:p>
-        </p:txBody>
-      </p:sp>
-      <p:sp>
-        <p:nvSpPr>
-          <p:cNvPr id="28" name="TextBox 27"/>
-          <p:cNvSpPr txBox="1"/>
-          <p:nvPr/>
-        </p:nvSpPr>
-        <p:spPr>
-          <a:xfrm>
-            <a:off x="9363455" y="2560320"/>
-            <a:ext cx="2148840" cy="347472"/>
-          </a:xfrm>
-          <a:prstGeom prst="rect">
-            <a:avLst/>
-          </a:prstGeom>
-          <a:noFill/>
-        </p:spPr>
-        <p:txBody>
-          <a:bodyPr wrap="square" lIns="54864" rIns="54864" tIns="54864" bIns="54864" anchor="t">
-            <a:spAutoFit/>
-          </a:bodyPr>
-          <a:lstStyle/>
-          <a:p>
-            <a:pPr algn="l"/>
-            <a:r>
-              <a:rPr sz="1800" b="1">
-                <a:solidFill>
-                  <a:srgbClr val="2B2A26"/>
-                </a:solidFill>
-                <a:latin typeface="Aptos"/>
-              </a:rPr>
-              <a:t>Transición</a:t>
-            </a:r>
-          </a:p>
-        </p:txBody>
-      </p:sp>
-      <p:sp>
-        <p:nvSpPr>
-          <p:cNvPr id="29" name="TextBox 28"/>
-          <p:cNvSpPr txBox="1"/>
-          <p:nvPr/>
-        </p:nvSpPr>
-        <p:spPr>
-          <a:xfrm>
-            <a:off x="9363455" y="3127248"/>
-            <a:ext cx="2212848" cy="1234440"/>
-          </a:xfrm>
-          <a:prstGeom prst="rect">
-            <a:avLst/>
-          </a:prstGeom>
-          <a:noFill/>
-        </p:spPr>
-        <p:txBody>
-          <a:bodyPr wrap="square" lIns="54864" rIns="54864" tIns="54864" bIns="54864" anchor="t">
-            <a:spAutoFit/>
-          </a:bodyPr>
-          <a:lstStyle/>
-          <a:p>
-            <a:pPr algn="l"/>
-            <a:r>
-              <a:rPr sz="1300" b="0">
-                <a:solidFill>
-                  <a:srgbClr val="2B2A26"/>
-                </a:solidFill>
-                <a:latin typeface="Aptos"/>
-              </a:rPr>
-              <a:t>Realizar pruebas finales, desplegar, capacitar usuarios y estabilizar el sistema.</a:t>
-            </a:r>
-          </a:p>
-        </p:txBody>
-      </p:sp>
-      <p:sp>
-        <p:nvSpPr>
-          <p:cNvPr id="30" name="Rectangle 29"/>
-          <p:cNvSpPr/>
-          <p:nvPr/>
-        </p:nvSpPr>
-        <p:spPr>
-          <a:xfrm>
-            <a:off x="9363455" y="4599432"/>
-            <a:ext cx="2176272" cy="18288"/>
-          </a:xfrm>
-          <a:prstGeom prst="rect">
-            <a:avLst/>
-          </a:prstGeom>
-          <a:solidFill>
-            <a:srgbClr val="664330"/>
-          </a:solidFill>
-          <a:ln>
-            <a:noFill/>
-          </a:ln>
-        </p:spPr>
-        <p:style>
-          <a:lnRef idx="1">
-            <a:schemeClr val="accent1"/>
-          </a:lnRef>
-          <a:fillRef idx="3">
-            <a:schemeClr val="accent1"/>
-          </a:fillRef>
-          <a:effectRef idx="2">
-            <a:schemeClr val="accent1"/>
-          </a:effectRef>
-          <a:fontRef idx="minor">
-            <a:schemeClr val="lt1"/>
-          </a:fontRef>
-        </p:style>
-        <p:txBody>
-          <a:bodyPr rtlCol="0" anchor="ctr"/>
-          <a:lstStyle/>
-          <a:p>
-            <a:pPr algn="ctr"/>
-          </a:p>
-        </p:txBody>
-      </p:sp>
-      <p:sp>
-        <p:nvSpPr>
-          <p:cNvPr id="31" name="TextBox 30"/>
-          <p:cNvSpPr txBox="1"/>
-          <p:nvPr/>
-        </p:nvSpPr>
-        <p:spPr>
-          <a:xfrm>
-            <a:off x="9363455" y="4800600"/>
-            <a:ext cx="2212848" cy="320040"/>
-          </a:xfrm>
-          <a:prstGeom prst="rect">
-            <a:avLst/>
-          </a:prstGeom>
-          <a:noFill/>
-        </p:spPr>
-        <p:txBody>
-          <a:bodyPr wrap="square" lIns="54864" rIns="54864" tIns="54864" bIns="54864" anchor="t">
-            <a:spAutoFit/>
-          </a:bodyPr>
-          <a:lstStyle/>
-          <a:p>
-            <a:pPr algn="l"/>
-            <a:r>
-              <a:rPr sz="1100" b="1">
-                <a:solidFill>
-                  <a:srgbClr val="664330"/>
-                </a:solidFill>
-                <a:latin typeface="Aptos"/>
-              </a:rPr>
-              <a:t>Artefactos: plan y manual de usuario</a:t>
-            </a:r>
-          </a:p>
-        </p:txBody>
-      </p:sp>
-      <p:sp>
-        <p:nvSpPr>
-          <p:cNvPr id="32" name="Chevron 31"/>
-          <p:cNvSpPr/>
-          <p:nvPr/>
-        </p:nvSpPr>
-        <p:spPr>
-          <a:xfrm>
-            <a:off x="3127248" y="3337560"/>
-            <a:ext cx="310896" cy="530352"/>
-          </a:xfrm>
-          <a:prstGeom prst="chevron">
-            <a:avLst/>
-          </a:prstGeom>
-          <a:solidFill>
-            <a:srgbClr val="FFFFFF"/>
-          </a:solidFill>
-          <a:ln>
-            <a:noFill/>
-          </a:ln>
-        </p:spPr>
-        <p:style>
-          <a:lnRef idx="1">
-            <a:schemeClr val="accent1"/>
-          </a:lnRef>
-          <a:fillRef idx="3">
-            <a:schemeClr val="accent1"/>
-          </a:fillRef>
-          <a:effectRef idx="2">
-            <a:schemeClr val="accent1"/>
-          </a:effectRef>
-          <a:fontRef idx="minor">
-            <a:schemeClr val="lt1"/>
-          </a:fontRef>
-        </p:style>
-        <p:txBody>
-          <a:bodyPr rtlCol="0" anchor="ctr"/>
-          <a:lstStyle/>
-          <a:p>
-            <a:pPr algn="ctr"/>
-          </a:p>
-        </p:txBody>
-      </p:sp>
-      <p:sp>
-        <p:nvSpPr>
-          <p:cNvPr id="33" name="Chevron 32"/>
-          <p:cNvSpPr/>
-          <p:nvPr/>
-        </p:nvSpPr>
-        <p:spPr>
-          <a:xfrm>
-            <a:off x="5998464" y="3337560"/>
-            <a:ext cx="310896" cy="530352"/>
-          </a:xfrm>
-          <a:prstGeom prst="chevron">
-            <a:avLst/>
-          </a:prstGeom>
-          <a:solidFill>
-            <a:srgbClr val="FFFFFF"/>
-          </a:solidFill>
-          <a:ln>
-            <a:noFill/>
-          </a:ln>
-        </p:spPr>
-        <p:style>
-          <a:lnRef idx="1">
-            <a:schemeClr val="accent1"/>
-          </a:lnRef>
-          <a:fillRef idx="3">
-            <a:schemeClr val="accent1"/>
-          </a:fillRef>
-          <a:effectRef idx="2">
-            <a:schemeClr val="accent1"/>
-          </a:effectRef>
-          <a:fontRef idx="minor">
-            <a:schemeClr val="lt1"/>
-          </a:fontRef>
-        </p:style>
-        <p:txBody>
-          <a:bodyPr rtlCol="0" anchor="ctr"/>
-          <a:lstStyle/>
-          <a:p>
-            <a:pPr algn="ctr"/>
-          </a:p>
-        </p:txBody>
-      </p:sp>
-      <p:sp>
-        <p:nvSpPr>
-          <p:cNvPr id="34" name="Chevron 33"/>
-          <p:cNvSpPr/>
-          <p:nvPr/>
-        </p:nvSpPr>
-        <p:spPr>
-          <a:xfrm>
-            <a:off x="8869680" y="3337560"/>
-            <a:ext cx="310896" cy="530352"/>
-          </a:xfrm>
-          <a:prstGeom prst="chevron">
-            <a:avLst/>
-          </a:prstGeom>
-          <a:solidFill>
-            <a:srgbClr val="FFFFFF"/>
-          </a:solidFill>
-          <a:ln>
-            <a:noFill/>
-          </a:ln>
-        </p:spPr>
-        <p:style>
-          <a:lnRef idx="1">
-            <a:schemeClr val="accent1"/>
-          </a:lnRef>
-          <a:fillRef idx="3">
-            <a:schemeClr val="accent1"/>
-          </a:fillRef>
-          <a:effectRef idx="2">
-            <a:schemeClr val="accent1"/>
-          </a:effectRef>
-          <a:fontRef idx="minor">
-            <a:schemeClr val="lt1"/>
-          </a:fontRef>
-        </p:style>
-        <p:txBody>
-          <a:bodyPr rtlCol="0" anchor="ctr"/>
-          <a:lstStyle/>
-          <a:p>
-            <a:pPr algn="ctr"/>
-          </a:p>
-        </p:txBody>
-      </p:sp>
-      <p:sp>
-        <p:nvSpPr>
-          <p:cNvPr id="35" name="TextBox 34"/>
-          <p:cNvSpPr txBox="1"/>
-          <p:nvPr/>
-        </p:nvSpPr>
-        <p:spPr>
-          <a:xfrm>
-            <a:off x="777240" y="5715000"/>
-            <a:ext cx="10652760" cy="475488"/>
-          </a:xfrm>
-          <a:prstGeom prst="rect">
-            <a:avLst/>
-          </a:prstGeom>
-          <a:noFill/>
-        </p:spPr>
-        <p:txBody>
-          <a:bodyPr wrap="square" lIns="54864" rIns="54864" tIns="54864" bIns="54864" anchor="t">
-            <a:spAutoFit/>
-          </a:bodyPr>
-          <a:lstStyle/>
-          <a:p>
-            <a:pPr algn="ctr"/>
-            <a:r>
-              <a:rPr sz="1300" b="1">
+            <a:r>
+              <a:rPr sz="1000" b="1">
                 <a:solidFill>
                   <a:srgbClr val="C04E5C"/>
                 </a:solidFill>

</xml_diff>